<commit_message>
docs: replace database slide with VCoi use case diagram
</commit_message>
<xml_diff>
--- a/docs/presentation/VCoi_TMDT_5_slide.pptx
+++ b/docs/presentation/VCoi_TMDT_5_slide.pptx
@@ -782,7 +782,7 @@
           <a:lstStyle/>
           <a:p>
             <a:r>
-              <a:t>Thiết kế cơ sở dữ liệu</a:t>
+              <a:t>Sơ đồ Use Case tổng quát</a:t>
             </a:r>
           </a:p>
           <a:p>
@@ -793,13 +793,13 @@
           <a:p/>
           <a:p>
             <a:r>
-              <a:t>ERD rút gọn nối người dùng với đơn thu gom, rồi tới các dòng vật liệu, phiếu cân, báo giá và khoản chi. Một đơn có nhiều vật liệu và có thể có nhiều phiên bản báo giá. Khóa ngoại giúp giữ quan hệ giữa các bản ghi. Version hỗ trợ từ chối thao tác trên bản đơn cũ; ràng buộc dữ liệu giới hạn một khoản chi hoàn tất cho mỗi đơn. Các bảng và snapshot giúp giữ lại thông tin đã chốt để đối chiếu.</a:t>
+              <a:t>Sơ đồ Use Case mô tả ba tác nhân tương tác với VCoi. Khách hàng đặt lịch thu gom và duyệt báo giá. Nhân viên cân, lập báo giá và ghi nhận khoản chi mô phỏng. Quản trị viên quản lý vật liệu, bảng giá, phân công nhân viên và xem thống kê khoản chi. Các chức năng nằm trong ranh giới hệ thống, còn tác nhân đứng bên ngoài. Mỗi vai trò chỉ thực hiện những thao tác được cấp quyền.</a:t>
             </a:r>
           </a:p>
           <a:p/>
           <a:p>
             <a:r>
-              <a:t>Ghi chú: Sơ đồ chỉ vẽ một số khóa ngoại, không phải ERD đầy đủ. Các bảng địa chỉ, danh mục, giá, khiếu nại và audit được lược bớt. Chỉ mô tả cơ chế trong code/schema; chưa tuyên bố kiểm chứng mọi race trên SQL Server.</a:t>
+              <a:t>Ghi chú: Sơ đồ rút gọn giữ tám use case chính, không phải toàn bộ chức năng của dự án. Theo dõi đơn, biên nhận, địa chỉ và khiếu nại được giới thiệu ở phân hệ hoặc demo. Các đường nối liền không có mũi tên là quan hệ tương tác, không thể hiện thứ tự xử lý. Đăng nhập và phân quyền là điều kiện chung; không thêm quan hệ include/extend khi chưa mô tả chính xác hành vi.</a:t>
             </a:r>
           </a:p>
           <a:p>
@@ -8504,7 +8504,7 @@
               </a:defRPr>
             </a:pPr>
             <a:r>
-              <a:t>04 / CƠ SỞ DỮ LIỆU</a:t>
+              <a:t>04 / USE CASE TỔNG QUÁT</a:t>
             </a:r>
           </a:p>
         </p:txBody>
@@ -8546,7 +8546,7 @@
               </a:defRPr>
             </a:pPr>
             <a:r>
-              <a:t>Dữ liệu bám theo từng bước giao dịch.</a:t>
+              <a:t>Ai sử dụng chức năng nào?</a:t>
             </a:r>
           </a:p>
         </p:txBody>
@@ -8588,7 +8588,7 @@
               </a:defRPr>
             </a:pPr>
             <a:r>
-              <a:t>ERD rút gọn • Các đường nối thể hiện một số khóa ngoại cốt lõi.</a:t>
+              <a:t>Ba tác nhân và các chức năng chính trong VCoi.</a:t>
             </a:r>
           </a:p>
         </p:txBody>
@@ -8720,51 +8720,106 @@
           </a:p>
         </p:txBody>
       </p:sp>
-      <p:cxnSp>
-        <p:nvCxnSpPr>
-          <p:cNvPr id="8" name="Connector 7"/>
-          <p:cNvCxnSpPr/>
-          <p:nvPr/>
-        </p:nvCxnSpPr>
-        <p:spPr>
-          <a:xfrm>
-            <a:off x="3136391" y="2770632"/>
-            <a:ext cx="310897" cy="0"/>
-          </a:xfrm>
-          <a:prstGeom prst="line">
-            <a:avLst/>
-          </a:prstGeom>
-          <a:ln w="19050">
+      <p:sp>
+        <p:nvSpPr>
+          <p:cNvPr id="8" name="Rectangle 7"/>
+          <p:cNvSpPr/>
+          <p:nvPr/>
+        </p:nvSpPr>
+        <p:spPr>
+          <a:xfrm>
+            <a:off x="1938528" y="2057400"/>
+            <a:ext cx="8302752" cy="3941063"/>
+          </a:xfrm>
+          <a:prstGeom prst="rect">
+            <a:avLst/>
+          </a:prstGeom>
+          <a:solidFill>
+            <a:srgbClr val="FFFFFF"/>
+          </a:solidFill>
+          <a:ln w="10160">
             <a:solidFill>
               <a:srgbClr val="2C6F4D"/>
             </a:solidFill>
           </a:ln>
         </p:spPr>
         <p:style>
-          <a:lnRef idx="2">
+          <a:lnRef idx="1">
             <a:schemeClr val="accent1"/>
           </a:lnRef>
-          <a:fillRef idx="0">
+          <a:fillRef idx="3">
             <a:schemeClr val="accent1"/>
           </a:fillRef>
-          <a:effectRef idx="1">
+          <a:effectRef idx="2">
             <a:schemeClr val="accent1"/>
           </a:effectRef>
           <a:fontRef idx="minor">
-            <a:schemeClr val="tx1"/>
+            <a:schemeClr val="lt1"/>
           </a:fontRef>
         </p:style>
-      </p:cxnSp>
-      <p:sp>
-        <p:nvSpPr>
-          <p:cNvPr id="9" name="TextBox 8"/>
+        <p:txBody>
+          <a:bodyPr rtlCol="0" anchor="ctr"/>
+          <a:lstStyle/>
+          <a:p>
+            <a:pPr algn="ctr"/>
+          </a:p>
+        </p:txBody>
+      </p:sp>
+      <p:sp>
+        <p:nvSpPr>
+          <p:cNvPr id="9" name="Rounded Rectangle 8"/>
+          <p:cNvSpPr/>
+          <p:nvPr/>
+        </p:nvSpPr>
+        <p:spPr>
+          <a:xfrm>
+            <a:off x="4645152" y="2221992"/>
+            <a:ext cx="2907792" cy="329184"/>
+          </a:xfrm>
+          <a:prstGeom prst="roundRect">
+            <a:avLst>
+              <a:gd name="adj" fmla="val 10000"/>
+            </a:avLst>
+          </a:prstGeom>
+          <a:solidFill>
+            <a:srgbClr val="153F32"/>
+          </a:solidFill>
+          <a:ln>
+            <a:noFill/>
+          </a:ln>
+        </p:spPr>
+        <p:style>
+          <a:lnRef idx="1">
+            <a:schemeClr val="accent1"/>
+          </a:lnRef>
+          <a:fillRef idx="3">
+            <a:schemeClr val="accent1"/>
+          </a:fillRef>
+          <a:effectRef idx="2">
+            <a:schemeClr val="accent1"/>
+          </a:effectRef>
+          <a:fontRef idx="minor">
+            <a:schemeClr val="lt1"/>
+          </a:fontRef>
+        </p:style>
+        <p:txBody>
+          <a:bodyPr rtlCol="0" anchor="ctr"/>
+          <a:lstStyle/>
+          <a:p>
+            <a:pPr algn="ctr"/>
+          </a:p>
+        </p:txBody>
+      </p:sp>
+      <p:sp>
+        <p:nvSpPr>
+          <p:cNvPr id="10" name="TextBox 9"/>
           <p:cNvSpPr txBox="1"/>
           <p:nvPr/>
         </p:nvSpPr>
         <p:spPr>
           <a:xfrm>
-            <a:off x="3177539" y="2523744"/>
-            <a:ext cx="118872" cy="182880"/>
+            <a:off x="4754880" y="2290572"/>
+            <a:ext cx="2688336" cy="219456"/>
           </a:xfrm>
           <a:prstGeom prst="rect">
             <a:avLst/>
@@ -8784,29 +8839,214 @@
               <a:spcAft>
                 <a:spcPts val="700"/>
               </a:spcAft>
-              <a:defRPr sz="1000" b="1">
-                <a:solidFill>
-                  <a:srgbClr val="2C6F4D"/>
+              <a:defRPr sz="1050" b="1">
+                <a:solidFill>
+                  <a:srgbClr val="FFFFFF"/>
                 </a:solidFill>
                 <a:latin typeface="Arial"/>
               </a:defRPr>
             </a:pPr>
             <a:r>
-              <a:t>1</a:t>
-            </a:r>
-          </a:p>
-        </p:txBody>
-      </p:sp>
-      <p:sp>
-        <p:nvSpPr>
-          <p:cNvPr id="10" name="TextBox 9"/>
+              <a:t>HỆ THỐNG VCOI</a:t>
+            </a:r>
+          </a:p>
+        </p:txBody>
+      </p:sp>
+      <p:sp>
+        <p:nvSpPr>
+          <p:cNvPr id="11" name="Oval 10"/>
+          <p:cNvSpPr/>
+          <p:nvPr/>
+        </p:nvSpPr>
+        <p:spPr>
+          <a:xfrm>
+            <a:off x="740664" y="2569464"/>
+            <a:ext cx="256032" cy="256032"/>
+          </a:xfrm>
+          <a:prstGeom prst="ellipse">
+            <a:avLst/>
+          </a:prstGeom>
+          <a:solidFill>
+            <a:srgbClr val="F4F6EF"/>
+          </a:solidFill>
+          <a:ln w="22860">
+            <a:solidFill>
+              <a:srgbClr val="2C6F4D"/>
+            </a:solidFill>
+          </a:ln>
+        </p:spPr>
+        <p:style>
+          <a:lnRef idx="1">
+            <a:schemeClr val="accent1"/>
+          </a:lnRef>
+          <a:fillRef idx="3">
+            <a:schemeClr val="accent1"/>
+          </a:fillRef>
+          <a:effectRef idx="2">
+            <a:schemeClr val="accent1"/>
+          </a:effectRef>
+          <a:fontRef idx="minor">
+            <a:schemeClr val="lt1"/>
+          </a:fontRef>
+        </p:style>
+        <p:txBody>
+          <a:bodyPr rtlCol="0" anchor="ctr"/>
+          <a:lstStyle/>
+          <a:p>
+            <a:pPr algn="ctr"/>
+          </a:p>
+        </p:txBody>
+      </p:sp>
+      <p:cxnSp>
+        <p:nvCxnSpPr>
+          <p:cNvPr id="12" name="Connector 11"/>
+          <p:cNvCxnSpPr/>
+          <p:nvPr/>
+        </p:nvCxnSpPr>
+        <p:spPr>
+          <a:xfrm>
+            <a:off x="868680" y="2825496"/>
+            <a:ext cx="0" cy="466344"/>
+          </a:xfrm>
+          <a:prstGeom prst="line">
+            <a:avLst/>
+          </a:prstGeom>
+          <a:ln w="22860">
+            <a:solidFill>
+              <a:srgbClr val="2C6F4D"/>
+            </a:solidFill>
+          </a:ln>
+        </p:spPr>
+        <p:style>
+          <a:lnRef idx="2">
+            <a:schemeClr val="accent1"/>
+          </a:lnRef>
+          <a:fillRef idx="0">
+            <a:schemeClr val="accent1"/>
+          </a:fillRef>
+          <a:effectRef idx="1">
+            <a:schemeClr val="accent1"/>
+          </a:effectRef>
+          <a:fontRef idx="minor">
+            <a:schemeClr val="tx1"/>
+          </a:fontRef>
+        </p:style>
+      </p:cxnSp>
+      <p:cxnSp>
+        <p:nvCxnSpPr>
+          <p:cNvPr id="13" name="Connector 12"/>
+          <p:cNvCxnSpPr/>
+          <p:nvPr/>
+        </p:nvCxnSpPr>
+        <p:spPr>
+          <a:xfrm>
+            <a:off x="621792" y="2999232"/>
+            <a:ext cx="493776" cy="0"/>
+          </a:xfrm>
+          <a:prstGeom prst="line">
+            <a:avLst/>
+          </a:prstGeom>
+          <a:ln w="22860">
+            <a:solidFill>
+              <a:srgbClr val="2C6F4D"/>
+            </a:solidFill>
+          </a:ln>
+        </p:spPr>
+        <p:style>
+          <a:lnRef idx="2">
+            <a:schemeClr val="accent1"/>
+          </a:lnRef>
+          <a:fillRef idx="0">
+            <a:schemeClr val="accent1"/>
+          </a:fillRef>
+          <a:effectRef idx="1">
+            <a:schemeClr val="accent1"/>
+          </a:effectRef>
+          <a:fontRef idx="minor">
+            <a:schemeClr val="tx1"/>
+          </a:fontRef>
+        </p:style>
+      </p:cxnSp>
+      <p:cxnSp>
+        <p:nvCxnSpPr>
+          <p:cNvPr id="14" name="Connector 13"/>
+          <p:cNvCxnSpPr/>
+          <p:nvPr/>
+        </p:nvCxnSpPr>
+        <p:spPr>
+          <a:xfrm flipH="1">
+            <a:off x="658368" y="3291840"/>
+            <a:ext cx="210312" cy="320040"/>
+          </a:xfrm>
+          <a:prstGeom prst="line">
+            <a:avLst/>
+          </a:prstGeom>
+          <a:ln w="22860">
+            <a:solidFill>
+              <a:srgbClr val="2C6F4D"/>
+            </a:solidFill>
+          </a:ln>
+        </p:spPr>
+        <p:style>
+          <a:lnRef idx="2">
+            <a:schemeClr val="accent1"/>
+          </a:lnRef>
+          <a:fillRef idx="0">
+            <a:schemeClr val="accent1"/>
+          </a:fillRef>
+          <a:effectRef idx="1">
+            <a:schemeClr val="accent1"/>
+          </a:effectRef>
+          <a:fontRef idx="minor">
+            <a:schemeClr val="tx1"/>
+          </a:fontRef>
+        </p:style>
+      </p:cxnSp>
+      <p:cxnSp>
+        <p:nvCxnSpPr>
+          <p:cNvPr id="15" name="Connector 14"/>
+          <p:cNvCxnSpPr/>
+          <p:nvPr/>
+        </p:nvCxnSpPr>
+        <p:spPr>
+          <a:xfrm>
+            <a:off x="868680" y="3291840"/>
+            <a:ext cx="210312" cy="320040"/>
+          </a:xfrm>
+          <a:prstGeom prst="line">
+            <a:avLst/>
+          </a:prstGeom>
+          <a:ln w="22860">
+            <a:solidFill>
+              <a:srgbClr val="2C6F4D"/>
+            </a:solidFill>
+          </a:ln>
+        </p:spPr>
+        <p:style>
+          <a:lnRef idx="2">
+            <a:schemeClr val="accent1"/>
+          </a:lnRef>
+          <a:fillRef idx="0">
+            <a:schemeClr val="accent1"/>
+          </a:fillRef>
+          <a:effectRef idx="1">
+            <a:schemeClr val="accent1"/>
+          </a:effectRef>
+          <a:fontRef idx="minor">
+            <a:schemeClr val="tx1"/>
+          </a:fontRef>
+        </p:style>
+      </p:cxnSp>
+      <p:sp>
+        <p:nvSpPr>
+          <p:cNvPr id="16" name="TextBox 15"/>
           <p:cNvSpPr txBox="1"/>
           <p:nvPr/>
         </p:nvSpPr>
         <p:spPr>
           <a:xfrm>
-            <a:off x="3300984" y="2523744"/>
-            <a:ext cx="137160" cy="182880"/>
+            <a:off x="64007" y="2176272"/>
+            <a:ext cx="1609344" cy="329184"/>
           </a:xfrm>
           <a:prstGeom prst="rect">
             <a:avLst/>
@@ -8819,41 +9059,86 @@
           </a:bodyPr>
           <a:lstStyle/>
           <a:p>
-            <a:pPr>
+            <a:pPr algn="ctr">
               <a:lnSpc>
                 <a:spcPct val="108000"/>
               </a:lnSpc>
               <a:spcAft>
                 <a:spcPts val="700"/>
               </a:spcAft>
-              <a:defRPr sz="1000" b="1">
-                <a:solidFill>
-                  <a:srgbClr val="2C6F4D"/>
+              <a:defRPr sz="1550" b="1">
+                <a:solidFill>
+                  <a:srgbClr val="1E3F32"/>
                 </a:solidFill>
                 <a:latin typeface="Arial"/>
               </a:defRPr>
             </a:pPr>
             <a:r>
-              <a:t>N</a:t>
-            </a:r>
+              <a:t>Khách hàng</a:t>
+            </a:r>
+          </a:p>
+        </p:txBody>
+      </p:sp>
+      <p:sp>
+        <p:nvSpPr>
+          <p:cNvPr id="17" name="Oval 16"/>
+          <p:cNvSpPr/>
+          <p:nvPr/>
+        </p:nvSpPr>
+        <p:spPr>
+          <a:xfrm>
+            <a:off x="740664" y="4489704"/>
+            <a:ext cx="256032" cy="256032"/>
+          </a:xfrm>
+          <a:prstGeom prst="ellipse">
+            <a:avLst/>
+          </a:prstGeom>
+          <a:solidFill>
+            <a:srgbClr val="F4F6EF"/>
+          </a:solidFill>
+          <a:ln w="22860">
+            <a:solidFill>
+              <a:srgbClr val="2C6F4D"/>
+            </a:solidFill>
+          </a:ln>
+        </p:spPr>
+        <p:style>
+          <a:lnRef idx="1">
+            <a:schemeClr val="accent1"/>
+          </a:lnRef>
+          <a:fillRef idx="3">
+            <a:schemeClr val="accent1"/>
+          </a:fillRef>
+          <a:effectRef idx="2">
+            <a:schemeClr val="accent1"/>
+          </a:effectRef>
+          <a:fontRef idx="minor">
+            <a:schemeClr val="lt1"/>
+          </a:fontRef>
+        </p:style>
+        <p:txBody>
+          <a:bodyPr rtlCol="0" anchor="ctr"/>
+          <a:lstStyle/>
+          <a:p>
+            <a:pPr algn="ctr"/>
           </a:p>
         </p:txBody>
       </p:sp>
       <p:cxnSp>
         <p:nvCxnSpPr>
-          <p:cNvPr id="11" name="Connector 10"/>
+          <p:cNvPr id="18" name="Connector 17"/>
           <p:cNvCxnSpPr/>
           <p:nvPr/>
         </p:nvCxnSpPr>
         <p:spPr>
           <a:xfrm>
-            <a:off x="5925312" y="2770632"/>
-            <a:ext cx="310896" cy="0"/>
+            <a:off x="868680" y="4745736"/>
+            <a:ext cx="0" cy="466344"/>
           </a:xfrm>
           <a:prstGeom prst="line">
             <a:avLst/>
           </a:prstGeom>
-          <a:ln w="19050">
+          <a:ln w="22860">
             <a:solidFill>
               <a:srgbClr val="2C6F4D"/>
             </a:solidFill>
@@ -8874,16 +9159,121 @@
           </a:fontRef>
         </p:style>
       </p:cxnSp>
-      <p:sp>
-        <p:nvSpPr>
-          <p:cNvPr id="12" name="TextBox 11"/>
+      <p:cxnSp>
+        <p:nvCxnSpPr>
+          <p:cNvPr id="19" name="Connector 18"/>
+          <p:cNvCxnSpPr/>
+          <p:nvPr/>
+        </p:nvCxnSpPr>
+        <p:spPr>
+          <a:xfrm>
+            <a:off x="621792" y="4919472"/>
+            <a:ext cx="493776" cy="0"/>
+          </a:xfrm>
+          <a:prstGeom prst="line">
+            <a:avLst/>
+          </a:prstGeom>
+          <a:ln w="22860">
+            <a:solidFill>
+              <a:srgbClr val="2C6F4D"/>
+            </a:solidFill>
+          </a:ln>
+        </p:spPr>
+        <p:style>
+          <a:lnRef idx="2">
+            <a:schemeClr val="accent1"/>
+          </a:lnRef>
+          <a:fillRef idx="0">
+            <a:schemeClr val="accent1"/>
+          </a:fillRef>
+          <a:effectRef idx="1">
+            <a:schemeClr val="accent1"/>
+          </a:effectRef>
+          <a:fontRef idx="minor">
+            <a:schemeClr val="tx1"/>
+          </a:fontRef>
+        </p:style>
+      </p:cxnSp>
+      <p:cxnSp>
+        <p:nvCxnSpPr>
+          <p:cNvPr id="20" name="Connector 19"/>
+          <p:cNvCxnSpPr/>
+          <p:nvPr/>
+        </p:nvCxnSpPr>
+        <p:spPr>
+          <a:xfrm flipH="1">
+            <a:off x="658368" y="5212080"/>
+            <a:ext cx="210312" cy="320040"/>
+          </a:xfrm>
+          <a:prstGeom prst="line">
+            <a:avLst/>
+          </a:prstGeom>
+          <a:ln w="22860">
+            <a:solidFill>
+              <a:srgbClr val="2C6F4D"/>
+            </a:solidFill>
+          </a:ln>
+        </p:spPr>
+        <p:style>
+          <a:lnRef idx="2">
+            <a:schemeClr val="accent1"/>
+          </a:lnRef>
+          <a:fillRef idx="0">
+            <a:schemeClr val="accent1"/>
+          </a:fillRef>
+          <a:effectRef idx="1">
+            <a:schemeClr val="accent1"/>
+          </a:effectRef>
+          <a:fontRef idx="minor">
+            <a:schemeClr val="tx1"/>
+          </a:fontRef>
+        </p:style>
+      </p:cxnSp>
+      <p:cxnSp>
+        <p:nvCxnSpPr>
+          <p:cNvPr id="21" name="Connector 20"/>
+          <p:cNvCxnSpPr/>
+          <p:nvPr/>
+        </p:nvCxnSpPr>
+        <p:spPr>
+          <a:xfrm>
+            <a:off x="868680" y="5212080"/>
+            <a:ext cx="210312" cy="320040"/>
+          </a:xfrm>
+          <a:prstGeom prst="line">
+            <a:avLst/>
+          </a:prstGeom>
+          <a:ln w="22860">
+            <a:solidFill>
+              <a:srgbClr val="2C6F4D"/>
+            </a:solidFill>
+          </a:ln>
+        </p:spPr>
+        <p:style>
+          <a:lnRef idx="2">
+            <a:schemeClr val="accent1"/>
+          </a:lnRef>
+          <a:fillRef idx="0">
+            <a:schemeClr val="accent1"/>
+          </a:fillRef>
+          <a:effectRef idx="1">
+            <a:schemeClr val="accent1"/>
+          </a:effectRef>
+          <a:fontRef idx="minor">
+            <a:schemeClr val="tx1"/>
+          </a:fontRef>
+        </p:style>
+      </p:cxnSp>
+      <p:sp>
+        <p:nvSpPr>
+          <p:cNvPr id="22" name="TextBox 21"/>
           <p:cNvSpPr txBox="1"/>
           <p:nvPr/>
         </p:nvSpPr>
         <p:spPr>
           <a:xfrm>
-            <a:off x="5966460" y="2523744"/>
-            <a:ext cx="118872" cy="182880"/>
+            <a:off x="64007" y="4096512"/>
+            <a:ext cx="1609344" cy="329184"/>
           </a:xfrm>
           <a:prstGeom prst="rect">
             <a:avLst/>
@@ -8896,36 +9286,221 @@
           </a:bodyPr>
           <a:lstStyle/>
           <a:p>
-            <a:pPr>
+            <a:pPr algn="ctr">
               <a:lnSpc>
                 <a:spcPct val="108000"/>
               </a:lnSpc>
               <a:spcAft>
                 <a:spcPts val="700"/>
               </a:spcAft>
-              <a:defRPr sz="1000" b="1">
-                <a:solidFill>
-                  <a:srgbClr val="2C6F4D"/>
+              <a:defRPr sz="1550" b="1">
+                <a:solidFill>
+                  <a:srgbClr val="1E3F32"/>
                 </a:solidFill>
                 <a:latin typeface="Arial"/>
               </a:defRPr>
             </a:pPr>
             <a:r>
-              <a:t>1</a:t>
-            </a:r>
-          </a:p>
-        </p:txBody>
-      </p:sp>
-      <p:sp>
-        <p:nvSpPr>
-          <p:cNvPr id="13" name="TextBox 12"/>
+              <a:t>Nhân viên</a:t>
+            </a:r>
+          </a:p>
+        </p:txBody>
+      </p:sp>
+      <p:sp>
+        <p:nvSpPr>
+          <p:cNvPr id="23" name="Oval 22"/>
+          <p:cNvSpPr/>
+          <p:nvPr/>
+        </p:nvSpPr>
+        <p:spPr>
+          <a:xfrm>
+            <a:off x="10863072" y="3236976"/>
+            <a:ext cx="256032" cy="256032"/>
+          </a:xfrm>
+          <a:prstGeom prst="ellipse">
+            <a:avLst/>
+          </a:prstGeom>
+          <a:solidFill>
+            <a:srgbClr val="F4F6EF"/>
+          </a:solidFill>
+          <a:ln w="22860">
+            <a:solidFill>
+              <a:srgbClr val="2C6F4D"/>
+            </a:solidFill>
+          </a:ln>
+        </p:spPr>
+        <p:style>
+          <a:lnRef idx="1">
+            <a:schemeClr val="accent1"/>
+          </a:lnRef>
+          <a:fillRef idx="3">
+            <a:schemeClr val="accent1"/>
+          </a:fillRef>
+          <a:effectRef idx="2">
+            <a:schemeClr val="accent1"/>
+          </a:effectRef>
+          <a:fontRef idx="minor">
+            <a:schemeClr val="lt1"/>
+          </a:fontRef>
+        </p:style>
+        <p:txBody>
+          <a:bodyPr rtlCol="0" anchor="ctr"/>
+          <a:lstStyle/>
+          <a:p>
+            <a:pPr algn="ctr"/>
+          </a:p>
+        </p:txBody>
+      </p:sp>
+      <p:cxnSp>
+        <p:nvCxnSpPr>
+          <p:cNvPr id="24" name="Connector 23"/>
+          <p:cNvCxnSpPr/>
+          <p:nvPr/>
+        </p:nvCxnSpPr>
+        <p:spPr>
+          <a:xfrm>
+            <a:off x="10991088" y="3493008"/>
+            <a:ext cx="0" cy="466344"/>
+          </a:xfrm>
+          <a:prstGeom prst="line">
+            <a:avLst/>
+          </a:prstGeom>
+          <a:ln w="22860">
+            <a:solidFill>
+              <a:srgbClr val="2C6F4D"/>
+            </a:solidFill>
+          </a:ln>
+        </p:spPr>
+        <p:style>
+          <a:lnRef idx="2">
+            <a:schemeClr val="accent1"/>
+          </a:lnRef>
+          <a:fillRef idx="0">
+            <a:schemeClr val="accent1"/>
+          </a:fillRef>
+          <a:effectRef idx="1">
+            <a:schemeClr val="accent1"/>
+          </a:effectRef>
+          <a:fontRef idx="minor">
+            <a:schemeClr val="tx1"/>
+          </a:fontRef>
+        </p:style>
+      </p:cxnSp>
+      <p:cxnSp>
+        <p:nvCxnSpPr>
+          <p:cNvPr id="25" name="Connector 24"/>
+          <p:cNvCxnSpPr/>
+          <p:nvPr/>
+        </p:nvCxnSpPr>
+        <p:spPr>
+          <a:xfrm>
+            <a:off x="10744200" y="3666744"/>
+            <a:ext cx="493776" cy="0"/>
+          </a:xfrm>
+          <a:prstGeom prst="line">
+            <a:avLst/>
+          </a:prstGeom>
+          <a:ln w="22860">
+            <a:solidFill>
+              <a:srgbClr val="2C6F4D"/>
+            </a:solidFill>
+          </a:ln>
+        </p:spPr>
+        <p:style>
+          <a:lnRef idx="2">
+            <a:schemeClr val="accent1"/>
+          </a:lnRef>
+          <a:fillRef idx="0">
+            <a:schemeClr val="accent1"/>
+          </a:fillRef>
+          <a:effectRef idx="1">
+            <a:schemeClr val="accent1"/>
+          </a:effectRef>
+          <a:fontRef idx="minor">
+            <a:schemeClr val="tx1"/>
+          </a:fontRef>
+        </p:style>
+      </p:cxnSp>
+      <p:cxnSp>
+        <p:nvCxnSpPr>
+          <p:cNvPr id="26" name="Connector 25"/>
+          <p:cNvCxnSpPr/>
+          <p:nvPr/>
+        </p:nvCxnSpPr>
+        <p:spPr>
+          <a:xfrm flipH="1">
+            <a:off x="10780776" y="3959352"/>
+            <a:ext cx="210312" cy="320040"/>
+          </a:xfrm>
+          <a:prstGeom prst="line">
+            <a:avLst/>
+          </a:prstGeom>
+          <a:ln w="22860">
+            <a:solidFill>
+              <a:srgbClr val="2C6F4D"/>
+            </a:solidFill>
+          </a:ln>
+        </p:spPr>
+        <p:style>
+          <a:lnRef idx="2">
+            <a:schemeClr val="accent1"/>
+          </a:lnRef>
+          <a:fillRef idx="0">
+            <a:schemeClr val="accent1"/>
+          </a:fillRef>
+          <a:effectRef idx="1">
+            <a:schemeClr val="accent1"/>
+          </a:effectRef>
+          <a:fontRef idx="minor">
+            <a:schemeClr val="tx1"/>
+          </a:fontRef>
+        </p:style>
+      </p:cxnSp>
+      <p:cxnSp>
+        <p:nvCxnSpPr>
+          <p:cNvPr id="27" name="Connector 26"/>
+          <p:cNvCxnSpPr/>
+          <p:nvPr/>
+        </p:nvCxnSpPr>
+        <p:spPr>
+          <a:xfrm>
+            <a:off x="10991088" y="3959352"/>
+            <a:ext cx="210312" cy="320040"/>
+          </a:xfrm>
+          <a:prstGeom prst="line">
+            <a:avLst/>
+          </a:prstGeom>
+          <a:ln w="22860">
+            <a:solidFill>
+              <a:srgbClr val="2C6F4D"/>
+            </a:solidFill>
+          </a:ln>
+        </p:spPr>
+        <p:style>
+          <a:lnRef idx="2">
+            <a:schemeClr val="accent1"/>
+          </a:lnRef>
+          <a:fillRef idx="0">
+            <a:schemeClr val="accent1"/>
+          </a:fillRef>
+          <a:effectRef idx="1">
+            <a:schemeClr val="accent1"/>
+          </a:effectRef>
+          <a:fontRef idx="minor">
+            <a:schemeClr val="tx1"/>
+          </a:fontRef>
+        </p:style>
+      </p:cxnSp>
+      <p:sp>
+        <p:nvSpPr>
+          <p:cNvPr id="28" name="TextBox 27"/>
           <p:cNvSpPr txBox="1"/>
           <p:nvPr/>
         </p:nvSpPr>
         <p:spPr>
           <a:xfrm>
-            <a:off x="6089904" y="2523744"/>
-            <a:ext cx="137160" cy="182880"/>
+            <a:off x="10186415" y="2816352"/>
+            <a:ext cx="1609344" cy="329184"/>
           </a:xfrm>
           <a:prstGeom prst="rect">
             <a:avLst/>
@@ -8938,617 +9513,22 @@
           </a:bodyPr>
           <a:lstStyle/>
           <a:p>
-            <a:pPr>
+            <a:pPr algn="ctr">
               <a:lnSpc>
                 <a:spcPct val="108000"/>
               </a:lnSpc>
               <a:spcAft>
                 <a:spcPts val="700"/>
               </a:spcAft>
-              <a:defRPr sz="1000" b="1">
-                <a:solidFill>
-                  <a:srgbClr val="2C6F4D"/>
+              <a:defRPr sz="1550" b="1">
+                <a:solidFill>
+                  <a:srgbClr val="1E3F32"/>
                 </a:solidFill>
                 <a:latin typeface="Arial"/>
               </a:defRPr>
             </a:pPr>
             <a:r>
-              <a:t>N</a:t>
-            </a:r>
-          </a:p>
-        </p:txBody>
-      </p:sp>
-      <p:cxnSp>
-        <p:nvCxnSpPr>
-          <p:cNvPr id="14" name="Connector 13"/>
-          <p:cNvCxnSpPr/>
-          <p:nvPr/>
-        </p:nvCxnSpPr>
-        <p:spPr>
-          <a:xfrm>
-            <a:off x="8714232" y="2770632"/>
-            <a:ext cx="310896" cy="0"/>
-          </a:xfrm>
-          <a:prstGeom prst="line">
-            <a:avLst/>
-          </a:prstGeom>
-          <a:ln w="19050">
-            <a:solidFill>
-              <a:srgbClr val="2C6F4D"/>
-            </a:solidFill>
-          </a:ln>
-        </p:spPr>
-        <p:style>
-          <a:lnRef idx="2">
-            <a:schemeClr val="accent1"/>
-          </a:lnRef>
-          <a:fillRef idx="0">
-            <a:schemeClr val="accent1"/>
-          </a:fillRef>
-          <a:effectRef idx="1">
-            <a:schemeClr val="accent1"/>
-          </a:effectRef>
-          <a:fontRef idx="minor">
-            <a:schemeClr val="tx1"/>
-          </a:fontRef>
-        </p:style>
-      </p:cxnSp>
-      <p:sp>
-        <p:nvSpPr>
-          <p:cNvPr id="15" name="TextBox 14"/>
-          <p:cNvSpPr txBox="1"/>
-          <p:nvPr/>
-        </p:nvSpPr>
-        <p:spPr>
-          <a:xfrm>
-            <a:off x="8755380" y="2523744"/>
-            <a:ext cx="118872" cy="182880"/>
-          </a:xfrm>
-          <a:prstGeom prst="rect">
-            <a:avLst/>
-          </a:prstGeom>
-          <a:noFill/>
-        </p:spPr>
-        <p:txBody>
-          <a:bodyPr wrap="square" lIns="0" rIns="0" tIns="0" bIns="0">
-            <a:spAutoFit/>
-          </a:bodyPr>
-          <a:lstStyle/>
-          <a:p>
-            <a:pPr>
-              <a:lnSpc>
-                <a:spcPct val="108000"/>
-              </a:lnSpc>
-              <a:spcAft>
-                <a:spcPts val="700"/>
-              </a:spcAft>
-              <a:defRPr sz="1000" b="1">
-                <a:solidFill>
-                  <a:srgbClr val="2C6F4D"/>
-                </a:solidFill>
-                <a:latin typeface="Arial"/>
-              </a:defRPr>
-            </a:pPr>
-            <a:r>
-              <a:t>1</a:t>
-            </a:r>
-          </a:p>
-        </p:txBody>
-      </p:sp>
-      <p:sp>
-        <p:nvSpPr>
-          <p:cNvPr id="16" name="TextBox 15"/>
-          <p:cNvSpPr txBox="1"/>
-          <p:nvPr/>
-        </p:nvSpPr>
-        <p:spPr>
-          <a:xfrm>
-            <a:off x="8878824" y="2523744"/>
-            <a:ext cx="137160" cy="182880"/>
-          </a:xfrm>
-          <a:prstGeom prst="rect">
-            <a:avLst/>
-          </a:prstGeom>
-          <a:noFill/>
-        </p:spPr>
-        <p:txBody>
-          <a:bodyPr wrap="square" lIns="0" rIns="0" tIns="0" bIns="0">
-            <a:spAutoFit/>
-          </a:bodyPr>
-          <a:lstStyle/>
-          <a:p>
-            <a:pPr>
-              <a:lnSpc>
-                <a:spcPct val="108000"/>
-              </a:lnSpc>
-              <a:spcAft>
-                <a:spcPts val="700"/>
-              </a:spcAft>
-              <a:defRPr sz="1000" b="1">
-                <a:solidFill>
-                  <a:srgbClr val="2C6F4D"/>
-                </a:solidFill>
-                <a:latin typeface="Arial"/>
-              </a:defRPr>
-            </a:pPr>
-            <a:r>
-              <a:t>N</a:t>
-            </a:r>
-          </a:p>
-        </p:txBody>
-      </p:sp>
-      <p:cxnSp>
-        <p:nvCxnSpPr>
-          <p:cNvPr id="17" name="Connector 16"/>
-          <p:cNvCxnSpPr/>
-          <p:nvPr/>
-        </p:nvCxnSpPr>
-        <p:spPr>
-          <a:xfrm>
-            <a:off x="3136391" y="4654296"/>
-            <a:ext cx="310897" cy="0"/>
-          </a:xfrm>
-          <a:prstGeom prst="line">
-            <a:avLst/>
-          </a:prstGeom>
-          <a:ln w="19050">
-            <a:solidFill>
-              <a:srgbClr val="2C6F4D"/>
-            </a:solidFill>
-          </a:ln>
-        </p:spPr>
-        <p:style>
-          <a:lnRef idx="2">
-            <a:schemeClr val="accent1"/>
-          </a:lnRef>
-          <a:fillRef idx="0">
-            <a:schemeClr val="accent1"/>
-          </a:fillRef>
-          <a:effectRef idx="1">
-            <a:schemeClr val="accent1"/>
-          </a:effectRef>
-          <a:fontRef idx="minor">
-            <a:schemeClr val="tx1"/>
-          </a:fontRef>
-        </p:style>
-      </p:cxnSp>
-      <p:sp>
-        <p:nvSpPr>
-          <p:cNvPr id="18" name="TextBox 17"/>
-          <p:cNvSpPr txBox="1"/>
-          <p:nvPr/>
-        </p:nvSpPr>
-        <p:spPr>
-          <a:xfrm>
-            <a:off x="3177539" y="4407408"/>
-            <a:ext cx="118872" cy="182880"/>
-          </a:xfrm>
-          <a:prstGeom prst="rect">
-            <a:avLst/>
-          </a:prstGeom>
-          <a:noFill/>
-        </p:spPr>
-        <p:txBody>
-          <a:bodyPr wrap="square" lIns="0" rIns="0" tIns="0" bIns="0">
-            <a:spAutoFit/>
-          </a:bodyPr>
-          <a:lstStyle/>
-          <a:p>
-            <a:pPr>
-              <a:lnSpc>
-                <a:spcPct val="108000"/>
-              </a:lnSpc>
-              <a:spcAft>
-                <a:spcPts val="700"/>
-              </a:spcAft>
-              <a:defRPr sz="1000" b="1">
-                <a:solidFill>
-                  <a:srgbClr val="2C6F4D"/>
-                </a:solidFill>
-                <a:latin typeface="Arial"/>
-              </a:defRPr>
-            </a:pPr>
-            <a:r>
-              <a:t>1</a:t>
-            </a:r>
-          </a:p>
-        </p:txBody>
-      </p:sp>
-      <p:sp>
-        <p:nvSpPr>
-          <p:cNvPr id="19" name="TextBox 18"/>
-          <p:cNvSpPr txBox="1"/>
-          <p:nvPr/>
-        </p:nvSpPr>
-        <p:spPr>
-          <a:xfrm>
-            <a:off x="3300984" y="4407408"/>
-            <a:ext cx="137160" cy="182880"/>
-          </a:xfrm>
-          <a:prstGeom prst="rect">
-            <a:avLst/>
-          </a:prstGeom>
-          <a:noFill/>
-        </p:spPr>
-        <p:txBody>
-          <a:bodyPr wrap="square" lIns="0" rIns="0" tIns="0" bIns="0">
-            <a:spAutoFit/>
-          </a:bodyPr>
-          <a:lstStyle/>
-          <a:p>
-            <a:pPr>
-              <a:lnSpc>
-                <a:spcPct val="108000"/>
-              </a:lnSpc>
-              <a:spcAft>
-                <a:spcPts val="700"/>
-              </a:spcAft>
-              <a:defRPr sz="1000" b="1">
-                <a:solidFill>
-                  <a:srgbClr val="2C6F4D"/>
-                </a:solidFill>
-                <a:latin typeface="Arial"/>
-              </a:defRPr>
-            </a:pPr>
-            <a:r>
-              <a:t>N</a:t>
-            </a:r>
-          </a:p>
-        </p:txBody>
-      </p:sp>
-      <p:cxnSp>
-        <p:nvCxnSpPr>
-          <p:cNvPr id="20" name="Connector 19"/>
-          <p:cNvCxnSpPr/>
-          <p:nvPr/>
-        </p:nvCxnSpPr>
-        <p:spPr>
-          <a:xfrm>
-            <a:off x="5925312" y="4654296"/>
-            <a:ext cx="310896" cy="0"/>
-          </a:xfrm>
-          <a:prstGeom prst="line">
-            <a:avLst/>
-          </a:prstGeom>
-          <a:ln w="19050">
-            <a:solidFill>
-              <a:srgbClr val="2C6F4D"/>
-            </a:solidFill>
-          </a:ln>
-        </p:spPr>
-        <p:style>
-          <a:lnRef idx="2">
-            <a:schemeClr val="accent1"/>
-          </a:lnRef>
-          <a:fillRef idx="0">
-            <a:schemeClr val="accent1"/>
-          </a:fillRef>
-          <a:effectRef idx="1">
-            <a:schemeClr val="accent1"/>
-          </a:effectRef>
-          <a:fontRef idx="minor">
-            <a:schemeClr val="tx1"/>
-          </a:fontRef>
-        </p:style>
-      </p:cxnSp>
-      <p:sp>
-        <p:nvSpPr>
-          <p:cNvPr id="21" name="TextBox 20"/>
-          <p:cNvSpPr txBox="1"/>
-          <p:nvPr/>
-        </p:nvSpPr>
-        <p:spPr>
-          <a:xfrm>
-            <a:off x="5966460" y="4407408"/>
-            <a:ext cx="118872" cy="182880"/>
-          </a:xfrm>
-          <a:prstGeom prst="rect">
-            <a:avLst/>
-          </a:prstGeom>
-          <a:noFill/>
-        </p:spPr>
-        <p:txBody>
-          <a:bodyPr wrap="square" lIns="0" rIns="0" tIns="0" bIns="0">
-            <a:spAutoFit/>
-          </a:bodyPr>
-          <a:lstStyle/>
-          <a:p>
-            <a:pPr>
-              <a:lnSpc>
-                <a:spcPct val="108000"/>
-              </a:lnSpc>
-              <a:spcAft>
-                <a:spcPts val="700"/>
-              </a:spcAft>
-              <a:defRPr sz="1000" b="1">
-                <a:solidFill>
-                  <a:srgbClr val="2C6F4D"/>
-                </a:solidFill>
-                <a:latin typeface="Arial"/>
-              </a:defRPr>
-            </a:pPr>
-            <a:r>
-              <a:t>1</a:t>
-            </a:r>
-          </a:p>
-        </p:txBody>
-      </p:sp>
-      <p:sp>
-        <p:nvSpPr>
-          <p:cNvPr id="22" name="TextBox 21"/>
-          <p:cNvSpPr txBox="1"/>
-          <p:nvPr/>
-        </p:nvSpPr>
-        <p:spPr>
-          <a:xfrm>
-            <a:off x="6089904" y="4407408"/>
-            <a:ext cx="137160" cy="182880"/>
-          </a:xfrm>
-          <a:prstGeom prst="rect">
-            <a:avLst/>
-          </a:prstGeom>
-          <a:noFill/>
-        </p:spPr>
-        <p:txBody>
-          <a:bodyPr wrap="square" lIns="0" rIns="0" tIns="0" bIns="0">
-            <a:spAutoFit/>
-          </a:bodyPr>
-          <a:lstStyle/>
-          <a:p>
-            <a:pPr>
-              <a:lnSpc>
-                <a:spcPct val="108000"/>
-              </a:lnSpc>
-              <a:spcAft>
-                <a:spcPts val="700"/>
-              </a:spcAft>
-              <a:defRPr sz="1000" b="1">
-                <a:solidFill>
-                  <a:srgbClr val="2C6F4D"/>
-                </a:solidFill>
-                <a:latin typeface="Arial"/>
-              </a:defRPr>
-            </a:pPr>
-            <a:r>
-              <a:t>N</a:t>
-            </a:r>
-          </a:p>
-        </p:txBody>
-      </p:sp>
-      <p:cxnSp>
-        <p:nvCxnSpPr>
-          <p:cNvPr id="23" name="Connector 22"/>
-          <p:cNvCxnSpPr/>
-          <p:nvPr/>
-        </p:nvCxnSpPr>
-        <p:spPr>
-          <a:xfrm>
-            <a:off x="8714232" y="4654296"/>
-            <a:ext cx="310896" cy="0"/>
-          </a:xfrm>
-          <a:prstGeom prst="line">
-            <a:avLst/>
-          </a:prstGeom>
-          <a:ln w="19050">
-            <a:solidFill>
-              <a:srgbClr val="2C6F4D"/>
-            </a:solidFill>
-          </a:ln>
-        </p:spPr>
-        <p:style>
-          <a:lnRef idx="2">
-            <a:schemeClr val="accent1"/>
-          </a:lnRef>
-          <a:fillRef idx="0">
-            <a:schemeClr val="accent1"/>
-          </a:fillRef>
-          <a:effectRef idx="1">
-            <a:schemeClr val="accent1"/>
-          </a:effectRef>
-          <a:fontRef idx="minor">
-            <a:schemeClr val="tx1"/>
-          </a:fontRef>
-        </p:style>
-      </p:cxnSp>
-      <p:sp>
-        <p:nvSpPr>
-          <p:cNvPr id="24" name="TextBox 23"/>
-          <p:cNvSpPr txBox="1"/>
-          <p:nvPr/>
-        </p:nvSpPr>
-        <p:spPr>
-          <a:xfrm>
-            <a:off x="8755380" y="4407408"/>
-            <a:ext cx="118872" cy="182880"/>
-          </a:xfrm>
-          <a:prstGeom prst="rect">
-            <a:avLst/>
-          </a:prstGeom>
-          <a:noFill/>
-        </p:spPr>
-        <p:txBody>
-          <a:bodyPr wrap="square" lIns="0" rIns="0" tIns="0" bIns="0">
-            <a:spAutoFit/>
-          </a:bodyPr>
-          <a:lstStyle/>
-          <a:p>
-            <a:pPr>
-              <a:lnSpc>
-                <a:spcPct val="108000"/>
-              </a:lnSpc>
-              <a:spcAft>
-                <a:spcPts val="700"/>
-              </a:spcAft>
-              <a:defRPr sz="1000" b="1">
-                <a:solidFill>
-                  <a:srgbClr val="2C6F4D"/>
-                </a:solidFill>
-                <a:latin typeface="Arial"/>
-              </a:defRPr>
-            </a:pPr>
-            <a:r>
-              <a:t>1</a:t>
-            </a:r>
-          </a:p>
-        </p:txBody>
-      </p:sp>
-      <p:sp>
-        <p:nvSpPr>
-          <p:cNvPr id="25" name="TextBox 24"/>
-          <p:cNvSpPr txBox="1"/>
-          <p:nvPr/>
-        </p:nvSpPr>
-        <p:spPr>
-          <a:xfrm>
-            <a:off x="8878824" y="4407408"/>
-            <a:ext cx="137160" cy="182880"/>
-          </a:xfrm>
-          <a:prstGeom prst="rect">
-            <a:avLst/>
-          </a:prstGeom>
-          <a:noFill/>
-        </p:spPr>
-        <p:txBody>
-          <a:bodyPr wrap="square" lIns="0" rIns="0" tIns="0" bIns="0">
-            <a:spAutoFit/>
-          </a:bodyPr>
-          <a:lstStyle/>
-          <a:p>
-            <a:pPr>
-              <a:lnSpc>
-                <a:spcPct val="108000"/>
-              </a:lnSpc>
-              <a:spcAft>
-                <a:spcPts val="700"/>
-              </a:spcAft>
-              <a:defRPr sz="1000" b="1">
-                <a:solidFill>
-                  <a:srgbClr val="2C6F4D"/>
-                </a:solidFill>
-                <a:latin typeface="Arial"/>
-              </a:defRPr>
-            </a:pPr>
-            <a:r>
-              <a:t>N</a:t>
-            </a:r>
-          </a:p>
-        </p:txBody>
-      </p:sp>
-      <p:cxnSp>
-        <p:nvCxnSpPr>
-          <p:cNvPr id="26" name="Connector 25"/>
-          <p:cNvCxnSpPr/>
-          <p:nvPr/>
-        </p:nvCxnSpPr>
-        <p:spPr>
-          <a:xfrm>
-            <a:off x="4686300" y="3328415"/>
-            <a:ext cx="0" cy="768097"/>
-          </a:xfrm>
-          <a:prstGeom prst="line">
-            <a:avLst/>
-          </a:prstGeom>
-          <a:ln w="19050">
-            <a:solidFill>
-              <a:srgbClr val="2C6F4D"/>
-            </a:solidFill>
-          </a:ln>
-        </p:spPr>
-        <p:style>
-          <a:lnRef idx="2">
-            <a:schemeClr val="accent1"/>
-          </a:lnRef>
-          <a:fillRef idx="0">
-            <a:schemeClr val="accent1"/>
-          </a:fillRef>
-          <a:effectRef idx="1">
-            <a:schemeClr val="accent1"/>
-          </a:effectRef>
-          <a:fontRef idx="minor">
-            <a:schemeClr val="tx1"/>
-          </a:fontRef>
-        </p:style>
-      </p:cxnSp>
-      <p:sp>
-        <p:nvSpPr>
-          <p:cNvPr id="27" name="TextBox 26"/>
-          <p:cNvSpPr txBox="1"/>
-          <p:nvPr/>
-        </p:nvSpPr>
-        <p:spPr>
-          <a:xfrm>
-            <a:off x="4759452" y="3419856"/>
-            <a:ext cx="182880" cy="182880"/>
-          </a:xfrm>
-          <a:prstGeom prst="rect">
-            <a:avLst/>
-          </a:prstGeom>
-          <a:noFill/>
-        </p:spPr>
-        <p:txBody>
-          <a:bodyPr wrap="square" lIns="0" rIns="0" tIns="0" bIns="0">
-            <a:spAutoFit/>
-          </a:bodyPr>
-          <a:lstStyle/>
-          <a:p>
-            <a:pPr>
-              <a:lnSpc>
-                <a:spcPct val="108000"/>
-              </a:lnSpc>
-              <a:spcAft>
-                <a:spcPts val="700"/>
-              </a:spcAft>
-              <a:defRPr sz="1000" b="1">
-                <a:solidFill>
-                  <a:srgbClr val="2C6F4D"/>
-                </a:solidFill>
-                <a:latin typeface="Arial"/>
-              </a:defRPr>
-            </a:pPr>
-            <a:r>
-              <a:t>1</a:t>
-            </a:r>
-          </a:p>
-        </p:txBody>
-      </p:sp>
-      <p:sp>
-        <p:nvSpPr>
-          <p:cNvPr id="28" name="TextBox 27"/>
-          <p:cNvSpPr txBox="1"/>
-          <p:nvPr/>
-        </p:nvSpPr>
-        <p:spPr>
-          <a:xfrm>
-            <a:off x="4759452" y="3849624"/>
-            <a:ext cx="182880" cy="182880"/>
-          </a:xfrm>
-          <a:prstGeom prst="rect">
-            <a:avLst/>
-          </a:prstGeom>
-          <a:noFill/>
-        </p:spPr>
-        <p:txBody>
-          <a:bodyPr wrap="square" lIns="0" rIns="0" tIns="0" bIns="0">
-            <a:spAutoFit/>
-          </a:bodyPr>
-          <a:lstStyle/>
-          <a:p>
-            <a:pPr>
-              <a:lnSpc>
-                <a:spcPct val="108000"/>
-              </a:lnSpc>
-              <a:spcAft>
-                <a:spcPts val="700"/>
-              </a:spcAft>
-              <a:defRPr sz="1000" b="1">
-                <a:solidFill>
-                  <a:srgbClr val="2C6F4D"/>
-                </a:solidFill>
-                <a:latin typeface="Arial"/>
-              </a:defRPr>
-            </a:pPr>
-            <a:r>
-              <a:t>N</a:t>
+              <a:t>Quản trị viên</a:t>
             </a:r>
           </a:p>
         </p:txBody>
@@ -9561,15 +9541,15 @@
         </p:nvCxnSpPr>
         <p:spPr>
           <a:xfrm>
-            <a:off x="7475220" y="3328415"/>
-            <a:ext cx="0" cy="420624"/>
+            <a:off x="1115568" y="2999232"/>
+            <a:ext cx="1380744" cy="0"/>
           </a:xfrm>
           <a:prstGeom prst="line">
             <a:avLst/>
           </a:prstGeom>
-          <a:ln w="19050">
+          <a:ln w="15240">
             <a:solidFill>
-              <a:srgbClr val="436D86"/>
+              <a:srgbClr val="2C6F4D"/>
             </a:solidFill>
           </a:ln>
         </p:spPr>
@@ -9596,15 +9576,15 @@
         </p:nvCxnSpPr>
         <p:spPr>
           <a:xfrm>
-            <a:off x="7475220" y="3749039"/>
-            <a:ext cx="2788920" cy="0"/>
+            <a:off x="1115568" y="2999232"/>
+            <a:ext cx="1380744" cy="777240"/>
           </a:xfrm>
           <a:prstGeom prst="line">
             <a:avLst/>
           </a:prstGeom>
-          <a:ln w="19050">
+          <a:ln w="15240">
             <a:solidFill>
-              <a:srgbClr val="436D86"/>
+              <a:srgbClr val="2C6F4D"/>
             </a:solidFill>
           </a:ln>
         </p:spPr>
@@ -9630,16 +9610,16 @@
           <p:nvPr/>
         </p:nvCxnSpPr>
         <p:spPr>
-          <a:xfrm>
-            <a:off x="10264140" y="3749039"/>
-            <a:ext cx="0" cy="347473"/>
+          <a:xfrm flipV="1">
+            <a:off x="1115568" y="4553712"/>
+            <a:ext cx="1380744" cy="365760"/>
           </a:xfrm>
           <a:prstGeom prst="line">
             <a:avLst/>
           </a:prstGeom>
-          <a:ln w="19050">
+          <a:ln w="15240">
             <a:solidFill>
-              <a:srgbClr val="436D86"/>
+              <a:srgbClr val="2C6F4D"/>
             </a:solidFill>
           </a:ln>
         </p:spPr>
@@ -9658,70 +9638,201 @@
           </a:fontRef>
         </p:style>
       </p:cxnSp>
-      <p:sp>
-        <p:nvSpPr>
-          <p:cNvPr id="32" name="TextBox 31"/>
-          <p:cNvSpPr txBox="1"/>
-          <p:nvPr/>
-        </p:nvSpPr>
-        <p:spPr>
-          <a:xfrm>
-            <a:off x="8375904" y="3456432"/>
-            <a:ext cx="1371600" cy="182880"/>
-          </a:xfrm>
-          <a:prstGeom prst="rect">
-            <a:avLst/>
-          </a:prstGeom>
-          <a:noFill/>
-        </p:spPr>
-        <p:txBody>
-          <a:bodyPr wrap="square" lIns="0" rIns="0" tIns="0" bIns="0">
-            <a:spAutoFit/>
-          </a:bodyPr>
-          <a:lstStyle/>
-          <a:p>
-            <a:pPr>
-              <a:lnSpc>
-                <a:spcPct val="108000"/>
-              </a:lnSpc>
-              <a:spcAft>
-                <a:spcPts val="700"/>
-              </a:spcAft>
-              <a:defRPr sz="950" b="0">
-                <a:solidFill>
-                  <a:srgbClr val="436D86"/>
-                </a:solidFill>
-                <a:latin typeface="Arial"/>
-              </a:defRPr>
-            </a:pPr>
-            <a:r>
-              <a:t>1 báo giá : N dòng</a:t>
-            </a:r>
-          </a:p>
-        </p:txBody>
-      </p:sp>
-      <p:sp>
-        <p:nvSpPr>
-          <p:cNvPr id="33" name="Rounded Rectangle 32"/>
+      <p:cxnSp>
+        <p:nvCxnSpPr>
+          <p:cNvPr id="32" name="Connector 31"/>
+          <p:cNvCxnSpPr/>
+          <p:nvPr/>
+        </p:nvCxnSpPr>
+        <p:spPr>
+          <a:xfrm>
+            <a:off x="1115568" y="4919472"/>
+            <a:ext cx="1380744" cy="411480"/>
+          </a:xfrm>
+          <a:prstGeom prst="line">
+            <a:avLst/>
+          </a:prstGeom>
+          <a:ln w="15240">
+            <a:solidFill>
+              <a:srgbClr val="2C6F4D"/>
+            </a:solidFill>
+          </a:ln>
+        </p:spPr>
+        <p:style>
+          <a:lnRef idx="2">
+            <a:schemeClr val="accent1"/>
+          </a:lnRef>
+          <a:fillRef idx="0">
+            <a:schemeClr val="accent1"/>
+          </a:fillRef>
+          <a:effectRef idx="1">
+            <a:schemeClr val="accent1"/>
+          </a:effectRef>
+          <a:fontRef idx="minor">
+            <a:schemeClr val="tx1"/>
+          </a:fontRef>
+        </p:style>
+      </p:cxnSp>
+      <p:cxnSp>
+        <p:nvCxnSpPr>
+          <p:cNvPr id="33" name="Connector 32"/>
+          <p:cNvCxnSpPr/>
+          <p:nvPr/>
+        </p:nvCxnSpPr>
+        <p:spPr>
+          <a:xfrm flipH="1" flipV="1">
+            <a:off x="9628632" y="2999232"/>
+            <a:ext cx="1115568" cy="667512"/>
+          </a:xfrm>
+          <a:prstGeom prst="line">
+            <a:avLst/>
+          </a:prstGeom>
+          <a:ln w="15240">
+            <a:solidFill>
+              <a:srgbClr val="2C6F4D"/>
+            </a:solidFill>
+          </a:ln>
+        </p:spPr>
+        <p:style>
+          <a:lnRef idx="2">
+            <a:schemeClr val="accent1"/>
+          </a:lnRef>
+          <a:fillRef idx="0">
+            <a:schemeClr val="accent1"/>
+          </a:fillRef>
+          <a:effectRef idx="1">
+            <a:schemeClr val="accent1"/>
+          </a:effectRef>
+          <a:fontRef idx="minor">
+            <a:schemeClr val="tx1"/>
+          </a:fontRef>
+        </p:style>
+      </p:cxnSp>
+      <p:cxnSp>
+        <p:nvCxnSpPr>
+          <p:cNvPr id="34" name="Connector 33"/>
+          <p:cNvCxnSpPr/>
+          <p:nvPr/>
+        </p:nvCxnSpPr>
+        <p:spPr>
+          <a:xfrm flipH="1">
+            <a:off x="9628632" y="3666744"/>
+            <a:ext cx="1115568" cy="109728"/>
+          </a:xfrm>
+          <a:prstGeom prst="line">
+            <a:avLst/>
+          </a:prstGeom>
+          <a:ln w="15240">
+            <a:solidFill>
+              <a:srgbClr val="2C6F4D"/>
+            </a:solidFill>
+          </a:ln>
+        </p:spPr>
+        <p:style>
+          <a:lnRef idx="2">
+            <a:schemeClr val="accent1"/>
+          </a:lnRef>
+          <a:fillRef idx="0">
+            <a:schemeClr val="accent1"/>
+          </a:fillRef>
+          <a:effectRef idx="1">
+            <a:schemeClr val="accent1"/>
+          </a:effectRef>
+          <a:fontRef idx="minor">
+            <a:schemeClr val="tx1"/>
+          </a:fontRef>
+        </p:style>
+      </p:cxnSp>
+      <p:cxnSp>
+        <p:nvCxnSpPr>
+          <p:cNvPr id="35" name="Connector 34"/>
+          <p:cNvCxnSpPr/>
+          <p:nvPr/>
+        </p:nvCxnSpPr>
+        <p:spPr>
+          <a:xfrm flipH="1">
+            <a:off x="9628632" y="3666744"/>
+            <a:ext cx="1115568" cy="886968"/>
+          </a:xfrm>
+          <a:prstGeom prst="line">
+            <a:avLst/>
+          </a:prstGeom>
+          <a:ln w="15240">
+            <a:solidFill>
+              <a:srgbClr val="2C6F4D"/>
+            </a:solidFill>
+          </a:ln>
+        </p:spPr>
+        <p:style>
+          <a:lnRef idx="2">
+            <a:schemeClr val="accent1"/>
+          </a:lnRef>
+          <a:fillRef idx="0">
+            <a:schemeClr val="accent1"/>
+          </a:fillRef>
+          <a:effectRef idx="1">
+            <a:schemeClr val="accent1"/>
+          </a:effectRef>
+          <a:fontRef idx="minor">
+            <a:schemeClr val="tx1"/>
+          </a:fontRef>
+        </p:style>
+      </p:cxnSp>
+      <p:cxnSp>
+        <p:nvCxnSpPr>
+          <p:cNvPr id="36" name="Connector 35"/>
+          <p:cNvCxnSpPr/>
+          <p:nvPr/>
+        </p:nvCxnSpPr>
+        <p:spPr>
+          <a:xfrm flipH="1">
+            <a:off x="9628632" y="3666744"/>
+            <a:ext cx="1115568" cy="1664208"/>
+          </a:xfrm>
+          <a:prstGeom prst="line">
+            <a:avLst/>
+          </a:prstGeom>
+          <a:ln w="15240">
+            <a:solidFill>
+              <a:srgbClr val="2C6F4D"/>
+            </a:solidFill>
+          </a:ln>
+        </p:spPr>
+        <p:style>
+          <a:lnRef idx="2">
+            <a:schemeClr val="accent1"/>
+          </a:lnRef>
+          <a:fillRef idx="0">
+            <a:schemeClr val="accent1"/>
+          </a:fillRef>
+          <a:effectRef idx="1">
+            <a:schemeClr val="accent1"/>
+          </a:effectRef>
+          <a:fontRef idx="minor">
+            <a:schemeClr val="tx1"/>
+          </a:fontRef>
+        </p:style>
+      </p:cxnSp>
+      <p:sp>
+        <p:nvSpPr>
+          <p:cNvPr id="37" name="Oval 36"/>
           <p:cNvSpPr/>
           <p:nvPr/>
         </p:nvSpPr>
         <p:spPr>
           <a:xfrm>
-            <a:off x="658368" y="2212848"/>
-            <a:ext cx="2478024" cy="1115568"/>
-          </a:xfrm>
-          <a:prstGeom prst="roundRect">
-            <a:avLst>
-              <a:gd name="adj" fmla="val 10000"/>
-            </a:avLst>
+            <a:off x="2496312" y="2706624"/>
+            <a:ext cx="3090672" cy="585216"/>
+          </a:xfrm>
+          <a:prstGeom prst="ellipse">
+            <a:avLst/>
           </a:prstGeom>
           <a:solidFill>
-            <a:srgbClr val="FFFFFF"/>
+            <a:srgbClr val="E8EFDF"/>
           </a:solidFill>
-          <a:ln w="10160">
+          <a:ln w="14604">
             <a:solidFill>
-              <a:srgbClr val="D8E2D5"/>
+              <a:srgbClr val="2C6F4D"/>
             </a:solidFill>
           </a:ln>
         </p:spPr>
@@ -9740,34 +9851,50 @@
           </a:fontRef>
         </p:style>
         <p:txBody>
-          <a:bodyPr rtlCol="0" anchor="ctr"/>
-          <a:lstStyle/>
-          <a:p>
-            <a:pPr algn="ctr"/>
-          </a:p>
-        </p:txBody>
-      </p:sp>
-      <p:sp>
-        <p:nvSpPr>
-          <p:cNvPr id="34" name="Rounded Rectangle 33"/>
+          <a:bodyPr rtlCol="0" anchor="ctr" tIns="0" bIns="0" wrap="none"/>
+          <a:lstStyle/>
+          <a:p>
+            <a:pPr algn="ctr">
+              <a:spcBef>
+                <a:spcPts val="0"/>
+              </a:spcBef>
+              <a:spcAft>
+                <a:spcPts val="0"/>
+              </a:spcAft>
+              <a:defRPr sz="1650">
+                <a:solidFill>
+                  <a:srgbClr val="1E3F32"/>
+                </a:solidFill>
+                <a:latin typeface="Arial"/>
+              </a:defRPr>
+            </a:pPr>
+            <a:r>
+              <a:t>Đặt lịch thu gom</a:t>
+            </a:r>
+          </a:p>
+        </p:txBody>
+      </p:sp>
+      <p:sp>
+        <p:nvSpPr>
+          <p:cNvPr id="38" name="Oval 37"/>
           <p:cNvSpPr/>
           <p:nvPr/>
         </p:nvSpPr>
         <p:spPr>
           <a:xfrm>
-            <a:off x="658368" y="2212848"/>
-            <a:ext cx="2478024" cy="393192"/>
-          </a:xfrm>
-          <a:prstGeom prst="roundRect">
-            <a:avLst>
-              <a:gd name="adj" fmla="val 10000"/>
-            </a:avLst>
+            <a:off x="2496312" y="3483864"/>
+            <a:ext cx="3090672" cy="585216"/>
+          </a:xfrm>
+          <a:prstGeom prst="ellipse">
+            <a:avLst/>
           </a:prstGeom>
           <a:solidFill>
-            <a:srgbClr val="153F32"/>
+            <a:srgbClr val="E8EFDF"/>
           </a:solidFill>
-          <a:ln>
-            <a:noFill/>
+          <a:ln w="14604">
+            <a:solidFill>
+              <a:srgbClr val="2C6F4D"/>
+            </a:solidFill>
           </a:ln>
         </p:spPr>
         <p:style>
@@ -9785,23 +9912,405 @@
           </a:fontRef>
         </p:style>
         <p:txBody>
-          <a:bodyPr rtlCol="0" anchor="ctr"/>
-          <a:lstStyle/>
-          <a:p>
-            <a:pPr algn="ctr"/>
-          </a:p>
-        </p:txBody>
-      </p:sp>
-      <p:sp>
-        <p:nvSpPr>
-          <p:cNvPr id="35" name="TextBox 34"/>
+          <a:bodyPr rtlCol="0" anchor="ctr" tIns="0" bIns="0" wrap="none"/>
+          <a:lstStyle/>
+          <a:p>
+            <a:pPr algn="ctr">
+              <a:spcBef>
+                <a:spcPts val="0"/>
+              </a:spcBef>
+              <a:spcAft>
+                <a:spcPts val="0"/>
+              </a:spcAft>
+              <a:defRPr sz="1650">
+                <a:solidFill>
+                  <a:srgbClr val="1E3F32"/>
+                </a:solidFill>
+                <a:latin typeface="Arial"/>
+              </a:defRPr>
+            </a:pPr>
+            <a:r>
+              <a:t>Duyệt báo giá</a:t>
+            </a:r>
+          </a:p>
+        </p:txBody>
+      </p:sp>
+      <p:sp>
+        <p:nvSpPr>
+          <p:cNvPr id="39" name="Oval 38"/>
+          <p:cNvSpPr/>
+          <p:nvPr/>
+        </p:nvSpPr>
+        <p:spPr>
+          <a:xfrm>
+            <a:off x="2496312" y="4261104"/>
+            <a:ext cx="3090672" cy="585216"/>
+          </a:xfrm>
+          <a:prstGeom prst="ellipse">
+            <a:avLst/>
+          </a:prstGeom>
+          <a:solidFill>
+            <a:srgbClr val="E8EFDF"/>
+          </a:solidFill>
+          <a:ln w="14604">
+            <a:solidFill>
+              <a:srgbClr val="2C6F4D"/>
+            </a:solidFill>
+          </a:ln>
+        </p:spPr>
+        <p:style>
+          <a:lnRef idx="1">
+            <a:schemeClr val="accent1"/>
+          </a:lnRef>
+          <a:fillRef idx="3">
+            <a:schemeClr val="accent1"/>
+          </a:fillRef>
+          <a:effectRef idx="2">
+            <a:schemeClr val="accent1"/>
+          </a:effectRef>
+          <a:fontRef idx="minor">
+            <a:schemeClr val="lt1"/>
+          </a:fontRef>
+        </p:style>
+        <p:txBody>
+          <a:bodyPr rtlCol="0" anchor="ctr" tIns="0" bIns="0" wrap="none"/>
+          <a:lstStyle/>
+          <a:p>
+            <a:pPr algn="ctr">
+              <a:spcBef>
+                <a:spcPts val="0"/>
+              </a:spcBef>
+              <a:spcAft>
+                <a:spcPts val="0"/>
+              </a:spcAft>
+              <a:defRPr sz="1650">
+                <a:solidFill>
+                  <a:srgbClr val="1E3F32"/>
+                </a:solidFill>
+                <a:latin typeface="Arial"/>
+              </a:defRPr>
+            </a:pPr>
+            <a:r>
+              <a:t>Cân và lập báo giá</a:t>
+            </a:r>
+          </a:p>
+        </p:txBody>
+      </p:sp>
+      <p:sp>
+        <p:nvSpPr>
+          <p:cNvPr id="40" name="Oval 39"/>
+          <p:cNvSpPr/>
+          <p:nvPr/>
+        </p:nvSpPr>
+        <p:spPr>
+          <a:xfrm>
+            <a:off x="2496312" y="5038344"/>
+            <a:ext cx="3090672" cy="585216"/>
+          </a:xfrm>
+          <a:prstGeom prst="ellipse">
+            <a:avLst/>
+          </a:prstGeom>
+          <a:solidFill>
+            <a:srgbClr val="E8EFDF"/>
+          </a:solidFill>
+          <a:ln w="14604">
+            <a:solidFill>
+              <a:srgbClr val="2C6F4D"/>
+            </a:solidFill>
+          </a:ln>
+        </p:spPr>
+        <p:style>
+          <a:lnRef idx="1">
+            <a:schemeClr val="accent1"/>
+          </a:lnRef>
+          <a:fillRef idx="3">
+            <a:schemeClr val="accent1"/>
+          </a:fillRef>
+          <a:effectRef idx="2">
+            <a:schemeClr val="accent1"/>
+          </a:effectRef>
+          <a:fontRef idx="minor">
+            <a:schemeClr val="lt1"/>
+          </a:fontRef>
+        </p:style>
+        <p:txBody>
+          <a:bodyPr rtlCol="0" anchor="ctr" tIns="0" bIns="0" wrap="none"/>
+          <a:lstStyle/>
+          <a:p>
+            <a:pPr algn="ctr">
+              <a:spcBef>
+                <a:spcPts val="0"/>
+              </a:spcBef>
+              <a:spcAft>
+                <a:spcPts val="0"/>
+              </a:spcAft>
+              <a:defRPr sz="1650">
+                <a:solidFill>
+                  <a:srgbClr val="1E3F32"/>
+                </a:solidFill>
+                <a:latin typeface="Arial"/>
+              </a:defRPr>
+            </a:pPr>
+            <a:r>
+              <a:t>Ghi khoản chi mô phỏng</a:t>
+            </a:r>
+          </a:p>
+        </p:txBody>
+      </p:sp>
+      <p:sp>
+        <p:nvSpPr>
+          <p:cNvPr id="41" name="Oval 40"/>
+          <p:cNvSpPr/>
+          <p:nvPr/>
+        </p:nvSpPr>
+        <p:spPr>
+          <a:xfrm>
+            <a:off x="6446520" y="2706624"/>
+            <a:ext cx="3182112" cy="585216"/>
+          </a:xfrm>
+          <a:prstGeom prst="ellipse">
+            <a:avLst/>
+          </a:prstGeom>
+          <a:solidFill>
+            <a:srgbClr val="F4F6EF"/>
+          </a:solidFill>
+          <a:ln w="14604">
+            <a:solidFill>
+              <a:srgbClr val="2C6F4D"/>
+            </a:solidFill>
+          </a:ln>
+        </p:spPr>
+        <p:style>
+          <a:lnRef idx="1">
+            <a:schemeClr val="accent1"/>
+          </a:lnRef>
+          <a:fillRef idx="3">
+            <a:schemeClr val="accent1"/>
+          </a:fillRef>
+          <a:effectRef idx="2">
+            <a:schemeClr val="accent1"/>
+          </a:effectRef>
+          <a:fontRef idx="minor">
+            <a:schemeClr val="lt1"/>
+          </a:fontRef>
+        </p:style>
+        <p:txBody>
+          <a:bodyPr rtlCol="0" anchor="ctr" tIns="0" bIns="0" wrap="none"/>
+          <a:lstStyle/>
+          <a:p>
+            <a:pPr algn="ctr">
+              <a:spcBef>
+                <a:spcPts val="0"/>
+              </a:spcBef>
+              <a:spcAft>
+                <a:spcPts val="0"/>
+              </a:spcAft>
+              <a:defRPr sz="1650">
+                <a:solidFill>
+                  <a:srgbClr val="1E3F32"/>
+                </a:solidFill>
+                <a:latin typeface="Arial"/>
+              </a:defRPr>
+            </a:pPr>
+            <a:r>
+              <a:t>Quản lý vật liệu</a:t>
+            </a:r>
+          </a:p>
+        </p:txBody>
+      </p:sp>
+      <p:sp>
+        <p:nvSpPr>
+          <p:cNvPr id="42" name="Oval 41"/>
+          <p:cNvSpPr/>
+          <p:nvPr/>
+        </p:nvSpPr>
+        <p:spPr>
+          <a:xfrm>
+            <a:off x="6446520" y="3483864"/>
+            <a:ext cx="3182112" cy="585216"/>
+          </a:xfrm>
+          <a:prstGeom prst="ellipse">
+            <a:avLst/>
+          </a:prstGeom>
+          <a:solidFill>
+            <a:srgbClr val="F4F6EF"/>
+          </a:solidFill>
+          <a:ln w="14604">
+            <a:solidFill>
+              <a:srgbClr val="2C6F4D"/>
+            </a:solidFill>
+          </a:ln>
+        </p:spPr>
+        <p:style>
+          <a:lnRef idx="1">
+            <a:schemeClr val="accent1"/>
+          </a:lnRef>
+          <a:fillRef idx="3">
+            <a:schemeClr val="accent1"/>
+          </a:fillRef>
+          <a:effectRef idx="2">
+            <a:schemeClr val="accent1"/>
+          </a:effectRef>
+          <a:fontRef idx="minor">
+            <a:schemeClr val="lt1"/>
+          </a:fontRef>
+        </p:style>
+        <p:txBody>
+          <a:bodyPr rtlCol="0" anchor="ctr" tIns="0" bIns="0" wrap="none"/>
+          <a:lstStyle/>
+          <a:p>
+            <a:pPr algn="ctr">
+              <a:spcBef>
+                <a:spcPts val="0"/>
+              </a:spcBef>
+              <a:spcAft>
+                <a:spcPts val="0"/>
+              </a:spcAft>
+              <a:defRPr sz="1650">
+                <a:solidFill>
+                  <a:srgbClr val="1E3F32"/>
+                </a:solidFill>
+                <a:latin typeface="Arial"/>
+              </a:defRPr>
+            </a:pPr>
+            <a:r>
+              <a:t>Quản lý bảng giá</a:t>
+            </a:r>
+          </a:p>
+        </p:txBody>
+      </p:sp>
+      <p:sp>
+        <p:nvSpPr>
+          <p:cNvPr id="43" name="Oval 42"/>
+          <p:cNvSpPr/>
+          <p:nvPr/>
+        </p:nvSpPr>
+        <p:spPr>
+          <a:xfrm>
+            <a:off x="6446520" y="4261104"/>
+            <a:ext cx="3182112" cy="585216"/>
+          </a:xfrm>
+          <a:prstGeom prst="ellipse">
+            <a:avLst/>
+          </a:prstGeom>
+          <a:solidFill>
+            <a:srgbClr val="F4F6EF"/>
+          </a:solidFill>
+          <a:ln w="14604">
+            <a:solidFill>
+              <a:srgbClr val="2C6F4D"/>
+            </a:solidFill>
+          </a:ln>
+        </p:spPr>
+        <p:style>
+          <a:lnRef idx="1">
+            <a:schemeClr val="accent1"/>
+          </a:lnRef>
+          <a:fillRef idx="3">
+            <a:schemeClr val="accent1"/>
+          </a:fillRef>
+          <a:effectRef idx="2">
+            <a:schemeClr val="accent1"/>
+          </a:effectRef>
+          <a:fontRef idx="minor">
+            <a:schemeClr val="lt1"/>
+          </a:fontRef>
+        </p:style>
+        <p:txBody>
+          <a:bodyPr rtlCol="0" anchor="ctr" tIns="0" bIns="0" wrap="none"/>
+          <a:lstStyle/>
+          <a:p>
+            <a:pPr algn="ctr">
+              <a:spcBef>
+                <a:spcPts val="0"/>
+              </a:spcBef>
+              <a:spcAft>
+                <a:spcPts val="0"/>
+              </a:spcAft>
+              <a:defRPr sz="1650">
+                <a:solidFill>
+                  <a:srgbClr val="1E3F32"/>
+                </a:solidFill>
+                <a:latin typeface="Arial"/>
+              </a:defRPr>
+            </a:pPr>
+            <a:r>
+              <a:t>Phân công nhân viên</a:t>
+            </a:r>
+          </a:p>
+        </p:txBody>
+      </p:sp>
+      <p:sp>
+        <p:nvSpPr>
+          <p:cNvPr id="44" name="Oval 43"/>
+          <p:cNvSpPr/>
+          <p:nvPr/>
+        </p:nvSpPr>
+        <p:spPr>
+          <a:xfrm>
+            <a:off x="6446520" y="5038344"/>
+            <a:ext cx="3182112" cy="585216"/>
+          </a:xfrm>
+          <a:prstGeom prst="ellipse">
+            <a:avLst/>
+          </a:prstGeom>
+          <a:solidFill>
+            <a:srgbClr val="F4F6EF"/>
+          </a:solidFill>
+          <a:ln w="14604">
+            <a:solidFill>
+              <a:srgbClr val="2C6F4D"/>
+            </a:solidFill>
+          </a:ln>
+        </p:spPr>
+        <p:style>
+          <a:lnRef idx="1">
+            <a:schemeClr val="accent1"/>
+          </a:lnRef>
+          <a:fillRef idx="3">
+            <a:schemeClr val="accent1"/>
+          </a:fillRef>
+          <a:effectRef idx="2">
+            <a:schemeClr val="accent1"/>
+          </a:effectRef>
+          <a:fontRef idx="minor">
+            <a:schemeClr val="lt1"/>
+          </a:fontRef>
+        </p:style>
+        <p:txBody>
+          <a:bodyPr rtlCol="0" anchor="ctr" tIns="0" bIns="0" wrap="none"/>
+          <a:lstStyle/>
+          <a:p>
+            <a:pPr algn="ctr">
+              <a:spcBef>
+                <a:spcPts val="0"/>
+              </a:spcBef>
+              <a:spcAft>
+                <a:spcPts val="0"/>
+              </a:spcAft>
+              <a:defRPr sz="1650">
+                <a:solidFill>
+                  <a:srgbClr val="1E3F32"/>
+                </a:solidFill>
+                <a:latin typeface="Arial"/>
+              </a:defRPr>
+            </a:pPr>
+            <a:r>
+              <a:t>Xem thống kê khoản chi</a:t>
+            </a:r>
+          </a:p>
+        </p:txBody>
+      </p:sp>
+      <p:sp>
+        <p:nvSpPr>
+          <p:cNvPr id="45" name="TextBox 44"/>
           <p:cNvSpPr txBox="1"/>
           <p:nvPr/>
         </p:nvSpPr>
         <p:spPr>
           <a:xfrm>
-            <a:off x="795528" y="2304288"/>
-            <a:ext cx="2203704" cy="237744"/>
+            <a:off x="2103120" y="6126480"/>
+            <a:ext cx="7955279" cy="219456"/>
           </a:xfrm>
           <a:prstGeom prst="rect">
             <a:avLst/>
@@ -9814,49 +10323,7 @@
           </a:bodyPr>
           <a:lstStyle/>
           <a:p>
-            <a:pPr>
-              <a:lnSpc>
-                <a:spcPct val="108000"/>
-              </a:lnSpc>
-              <a:spcAft>
-                <a:spcPts val="700"/>
-              </a:spcAft>
-              <a:defRPr sz="1500" b="1">
-                <a:solidFill>
-                  <a:srgbClr val="FFFFFF"/>
-                </a:solidFill>
-                <a:latin typeface="Arial"/>
-              </a:defRPr>
-            </a:pPr>
-            <a:r>
-              <a:t>users</a:t>
-            </a:r>
-          </a:p>
-        </p:txBody>
-      </p:sp>
-      <p:sp>
-        <p:nvSpPr>
-          <p:cNvPr id="36" name="TextBox 35"/>
-          <p:cNvSpPr txBox="1"/>
-          <p:nvPr/>
-        </p:nvSpPr>
-        <p:spPr>
-          <a:xfrm>
-            <a:off x="795528" y="2907791"/>
-            <a:ext cx="2203704" cy="237744"/>
-          </a:xfrm>
-          <a:prstGeom prst="rect">
-            <a:avLst/>
-          </a:prstGeom>
-          <a:noFill/>
-        </p:spPr>
-        <p:txBody>
-          <a:bodyPr wrap="square" lIns="0" rIns="0" tIns="0" bIns="0">
-            <a:spAutoFit/>
-          </a:bodyPr>
-          <a:lstStyle/>
-          <a:p>
-            <a:pPr>
+            <a:pPr algn="ctr">
               <a:lnSpc>
                 <a:spcPct val="108000"/>
               </a:lnSpc>
@@ -9865,1506 +10332,13 @@
               </a:spcAft>
               <a:defRPr sz="1150" b="0">
                 <a:solidFill>
-                  <a:srgbClr val="63756A"/>
+                  <a:srgbClr val="2C6F4D"/>
                 </a:solidFill>
                 <a:latin typeface="Arial"/>
               </a:defRPr>
             </a:pPr>
             <a:r>
-              <a:t>user_id · role</a:t>
-            </a:r>
-          </a:p>
-        </p:txBody>
-      </p:sp>
-      <p:sp>
-        <p:nvSpPr>
-          <p:cNvPr id="37" name="Rounded Rectangle 36"/>
-          <p:cNvSpPr/>
-          <p:nvPr/>
-        </p:nvSpPr>
-        <p:spPr>
-          <a:xfrm>
-            <a:off x="3447288" y="2212848"/>
-            <a:ext cx="2478024" cy="1115568"/>
-          </a:xfrm>
-          <a:prstGeom prst="roundRect">
-            <a:avLst>
-              <a:gd name="adj" fmla="val 10000"/>
-            </a:avLst>
-          </a:prstGeom>
-          <a:solidFill>
-            <a:srgbClr val="FFFFFF"/>
-          </a:solidFill>
-          <a:ln w="10160">
-            <a:solidFill>
-              <a:srgbClr val="D8E2D5"/>
-            </a:solidFill>
-          </a:ln>
-        </p:spPr>
-        <p:style>
-          <a:lnRef idx="1">
-            <a:schemeClr val="accent1"/>
-          </a:lnRef>
-          <a:fillRef idx="3">
-            <a:schemeClr val="accent1"/>
-          </a:fillRef>
-          <a:effectRef idx="2">
-            <a:schemeClr val="accent1"/>
-          </a:effectRef>
-          <a:fontRef idx="minor">
-            <a:schemeClr val="lt1"/>
-          </a:fontRef>
-        </p:style>
-        <p:txBody>
-          <a:bodyPr rtlCol="0" anchor="ctr"/>
-          <a:lstStyle/>
-          <a:p>
-            <a:pPr algn="ctr"/>
-          </a:p>
-        </p:txBody>
-      </p:sp>
-      <p:sp>
-        <p:nvSpPr>
-          <p:cNvPr id="38" name="Rounded Rectangle 37"/>
-          <p:cNvSpPr/>
-          <p:nvPr/>
-        </p:nvSpPr>
-        <p:spPr>
-          <a:xfrm>
-            <a:off x="3447288" y="2212848"/>
-            <a:ext cx="2478024" cy="393192"/>
-          </a:xfrm>
-          <a:prstGeom prst="roundRect">
-            <a:avLst>
-              <a:gd name="adj" fmla="val 10000"/>
-            </a:avLst>
-          </a:prstGeom>
-          <a:solidFill>
-            <a:srgbClr val="153F32"/>
-          </a:solidFill>
-          <a:ln>
-            <a:noFill/>
-          </a:ln>
-        </p:spPr>
-        <p:style>
-          <a:lnRef idx="1">
-            <a:schemeClr val="accent1"/>
-          </a:lnRef>
-          <a:fillRef idx="3">
-            <a:schemeClr val="accent1"/>
-          </a:fillRef>
-          <a:effectRef idx="2">
-            <a:schemeClr val="accent1"/>
-          </a:effectRef>
-          <a:fontRef idx="minor">
-            <a:schemeClr val="lt1"/>
-          </a:fontRef>
-        </p:style>
-        <p:txBody>
-          <a:bodyPr rtlCol="0" anchor="ctr"/>
-          <a:lstStyle/>
-          <a:p>
-            <a:pPr algn="ctr"/>
-          </a:p>
-        </p:txBody>
-      </p:sp>
-      <p:sp>
-        <p:nvSpPr>
-          <p:cNvPr id="39" name="TextBox 38"/>
-          <p:cNvSpPr txBox="1"/>
-          <p:nvPr/>
-        </p:nvSpPr>
-        <p:spPr>
-          <a:xfrm>
-            <a:off x="3584448" y="2304288"/>
-            <a:ext cx="2203704" cy="237744"/>
-          </a:xfrm>
-          <a:prstGeom prst="rect">
-            <a:avLst/>
-          </a:prstGeom>
-          <a:noFill/>
-        </p:spPr>
-        <p:txBody>
-          <a:bodyPr wrap="square" lIns="0" rIns="0" tIns="0" bIns="0">
-            <a:spAutoFit/>
-          </a:bodyPr>
-          <a:lstStyle/>
-          <a:p>
-            <a:pPr>
-              <a:lnSpc>
-                <a:spcPct val="108000"/>
-              </a:lnSpc>
-              <a:spcAft>
-                <a:spcPts val="700"/>
-              </a:spcAft>
-              <a:defRPr sz="1500" b="1">
-                <a:solidFill>
-                  <a:srgbClr val="FFFFFF"/>
-                </a:solidFill>
-                <a:latin typeface="Arial"/>
-              </a:defRPr>
-            </a:pPr>
-            <a:r>
-              <a:t>collection_orders</a:t>
-            </a:r>
-          </a:p>
-        </p:txBody>
-      </p:sp>
-      <p:sp>
-        <p:nvSpPr>
-          <p:cNvPr id="40" name="TextBox 39"/>
-          <p:cNvSpPr txBox="1"/>
-          <p:nvPr/>
-        </p:nvSpPr>
-        <p:spPr>
-          <a:xfrm>
-            <a:off x="3584448" y="2907791"/>
-            <a:ext cx="2203704" cy="237744"/>
-          </a:xfrm>
-          <a:prstGeom prst="rect">
-            <a:avLst/>
-          </a:prstGeom>
-          <a:noFill/>
-        </p:spPr>
-        <p:txBody>
-          <a:bodyPr wrap="square" lIns="0" rIns="0" tIns="0" bIns="0">
-            <a:spAutoFit/>
-          </a:bodyPr>
-          <a:lstStyle/>
-          <a:p>
-            <a:pPr>
-              <a:lnSpc>
-                <a:spcPct val="108000"/>
-              </a:lnSpc>
-              <a:spcAft>
-                <a:spcPts val="700"/>
-              </a:spcAft>
-              <a:defRPr sz="1150" b="0">
-                <a:solidFill>
-                  <a:srgbClr val="63756A"/>
-                </a:solidFill>
-                <a:latin typeface="Arial"/>
-              </a:defRPr>
-            </a:pPr>
-            <a:r>
-              <a:t>order_id · seller_user_id</a:t>
-            </a:r>
-          </a:p>
-        </p:txBody>
-      </p:sp>
-      <p:sp>
-        <p:nvSpPr>
-          <p:cNvPr id="41" name="Rounded Rectangle 40"/>
-          <p:cNvSpPr/>
-          <p:nvPr/>
-        </p:nvSpPr>
-        <p:spPr>
-          <a:xfrm>
-            <a:off x="6236208" y="2212848"/>
-            <a:ext cx="2478024" cy="1115568"/>
-          </a:xfrm>
-          <a:prstGeom prst="roundRect">
-            <a:avLst>
-              <a:gd name="adj" fmla="val 10000"/>
-            </a:avLst>
-          </a:prstGeom>
-          <a:solidFill>
-            <a:srgbClr val="FFFFFF"/>
-          </a:solidFill>
-          <a:ln w="10160">
-            <a:solidFill>
-              <a:srgbClr val="D8E2D5"/>
-            </a:solidFill>
-          </a:ln>
-        </p:spPr>
-        <p:style>
-          <a:lnRef idx="1">
-            <a:schemeClr val="accent1"/>
-          </a:lnRef>
-          <a:fillRef idx="3">
-            <a:schemeClr val="accent1"/>
-          </a:fillRef>
-          <a:effectRef idx="2">
-            <a:schemeClr val="accent1"/>
-          </a:effectRef>
-          <a:fontRef idx="minor">
-            <a:schemeClr val="lt1"/>
-          </a:fontRef>
-        </p:style>
-        <p:txBody>
-          <a:bodyPr rtlCol="0" anchor="ctr"/>
-          <a:lstStyle/>
-          <a:p>
-            <a:pPr algn="ctr"/>
-          </a:p>
-        </p:txBody>
-      </p:sp>
-      <p:sp>
-        <p:nvSpPr>
-          <p:cNvPr id="42" name="Rounded Rectangle 41"/>
-          <p:cNvSpPr/>
-          <p:nvPr/>
-        </p:nvSpPr>
-        <p:spPr>
-          <a:xfrm>
-            <a:off x="6236208" y="2212848"/>
-            <a:ext cx="2478024" cy="393192"/>
-          </a:xfrm>
-          <a:prstGeom prst="roundRect">
-            <a:avLst>
-              <a:gd name="adj" fmla="val 10000"/>
-            </a:avLst>
-          </a:prstGeom>
-          <a:solidFill>
-            <a:srgbClr val="153F32"/>
-          </a:solidFill>
-          <a:ln>
-            <a:noFill/>
-          </a:ln>
-        </p:spPr>
-        <p:style>
-          <a:lnRef idx="1">
-            <a:schemeClr val="accent1"/>
-          </a:lnRef>
-          <a:fillRef idx="3">
-            <a:schemeClr val="accent1"/>
-          </a:fillRef>
-          <a:effectRef idx="2">
-            <a:schemeClr val="accent1"/>
-          </a:effectRef>
-          <a:fontRef idx="minor">
-            <a:schemeClr val="lt1"/>
-          </a:fontRef>
-        </p:style>
-        <p:txBody>
-          <a:bodyPr rtlCol="0" anchor="ctr"/>
-          <a:lstStyle/>
-          <a:p>
-            <a:pPr algn="ctr"/>
-          </a:p>
-        </p:txBody>
-      </p:sp>
-      <p:sp>
-        <p:nvSpPr>
-          <p:cNvPr id="43" name="TextBox 42"/>
-          <p:cNvSpPr txBox="1"/>
-          <p:nvPr/>
-        </p:nvSpPr>
-        <p:spPr>
-          <a:xfrm>
-            <a:off x="6373368" y="2304288"/>
-            <a:ext cx="2203704" cy="237744"/>
-          </a:xfrm>
-          <a:prstGeom prst="rect">
-            <a:avLst/>
-          </a:prstGeom>
-          <a:noFill/>
-        </p:spPr>
-        <p:txBody>
-          <a:bodyPr wrap="square" lIns="0" rIns="0" tIns="0" bIns="0">
-            <a:spAutoFit/>
-          </a:bodyPr>
-          <a:lstStyle/>
-          <a:p>
-            <a:pPr>
-              <a:lnSpc>
-                <a:spcPct val="108000"/>
-              </a:lnSpc>
-              <a:spcAft>
-                <a:spcPts val="700"/>
-              </a:spcAft>
-              <a:defRPr sz="1500" b="1">
-                <a:solidFill>
-                  <a:srgbClr val="FFFFFF"/>
-                </a:solidFill>
-                <a:latin typeface="Arial"/>
-              </a:defRPr>
-            </a:pPr>
-            <a:r>
-              <a:t>order_quotes</a:t>
-            </a:r>
-          </a:p>
-        </p:txBody>
-      </p:sp>
-      <p:sp>
-        <p:nvSpPr>
-          <p:cNvPr id="44" name="TextBox 43"/>
-          <p:cNvSpPr txBox="1"/>
-          <p:nvPr/>
-        </p:nvSpPr>
-        <p:spPr>
-          <a:xfrm>
-            <a:off x="6373368" y="2907791"/>
-            <a:ext cx="2203704" cy="237744"/>
-          </a:xfrm>
-          <a:prstGeom prst="rect">
-            <a:avLst/>
-          </a:prstGeom>
-          <a:noFill/>
-        </p:spPr>
-        <p:txBody>
-          <a:bodyPr wrap="square" lIns="0" rIns="0" tIns="0" bIns="0">
-            <a:spAutoFit/>
-          </a:bodyPr>
-          <a:lstStyle/>
-          <a:p>
-            <a:pPr>
-              <a:lnSpc>
-                <a:spcPct val="108000"/>
-              </a:lnSpc>
-              <a:spcAft>
-                <a:spcPts val="700"/>
-              </a:spcAft>
-              <a:defRPr sz="1150" b="0">
-                <a:solidFill>
-                  <a:srgbClr val="63756A"/>
-                </a:solidFill>
-                <a:latin typeface="Arial"/>
-              </a:defRPr>
-            </a:pPr>
-            <a:r>
-              <a:t>quote_id · order_id</a:t>
-            </a:r>
-          </a:p>
-        </p:txBody>
-      </p:sp>
-      <p:sp>
-        <p:nvSpPr>
-          <p:cNvPr id="45" name="Rounded Rectangle 44"/>
-          <p:cNvSpPr/>
-          <p:nvPr/>
-        </p:nvSpPr>
-        <p:spPr>
-          <a:xfrm>
-            <a:off x="9025128" y="2212848"/>
-            <a:ext cx="2478024" cy="1115568"/>
-          </a:xfrm>
-          <a:prstGeom prst="roundRect">
-            <a:avLst>
-              <a:gd name="adj" fmla="val 10000"/>
-            </a:avLst>
-          </a:prstGeom>
-          <a:solidFill>
-            <a:srgbClr val="FFFFFF"/>
-          </a:solidFill>
-          <a:ln w="10160">
-            <a:solidFill>
-              <a:srgbClr val="D8E2D5"/>
-            </a:solidFill>
-          </a:ln>
-        </p:spPr>
-        <p:style>
-          <a:lnRef idx="1">
-            <a:schemeClr val="accent1"/>
-          </a:lnRef>
-          <a:fillRef idx="3">
-            <a:schemeClr val="accent1"/>
-          </a:fillRef>
-          <a:effectRef idx="2">
-            <a:schemeClr val="accent1"/>
-          </a:effectRef>
-          <a:fontRef idx="minor">
-            <a:schemeClr val="lt1"/>
-          </a:fontRef>
-        </p:style>
-        <p:txBody>
-          <a:bodyPr rtlCol="0" anchor="ctr"/>
-          <a:lstStyle/>
-          <a:p>
-            <a:pPr algn="ctr"/>
-          </a:p>
-        </p:txBody>
-      </p:sp>
-      <p:sp>
-        <p:nvSpPr>
-          <p:cNvPr id="46" name="Rounded Rectangle 45"/>
-          <p:cNvSpPr/>
-          <p:nvPr/>
-        </p:nvSpPr>
-        <p:spPr>
-          <a:xfrm>
-            <a:off x="9025128" y="2212848"/>
-            <a:ext cx="2478024" cy="393192"/>
-          </a:xfrm>
-          <a:prstGeom prst="roundRect">
-            <a:avLst>
-              <a:gd name="adj" fmla="val 10000"/>
-            </a:avLst>
-          </a:prstGeom>
-          <a:solidFill>
-            <a:srgbClr val="153F32"/>
-          </a:solidFill>
-          <a:ln>
-            <a:noFill/>
-          </a:ln>
-        </p:spPr>
-        <p:style>
-          <a:lnRef idx="1">
-            <a:schemeClr val="accent1"/>
-          </a:lnRef>
-          <a:fillRef idx="3">
-            <a:schemeClr val="accent1"/>
-          </a:fillRef>
-          <a:effectRef idx="2">
-            <a:schemeClr val="accent1"/>
-          </a:effectRef>
-          <a:fontRef idx="minor">
-            <a:schemeClr val="lt1"/>
-          </a:fontRef>
-        </p:style>
-        <p:txBody>
-          <a:bodyPr rtlCol="0" anchor="ctr"/>
-          <a:lstStyle/>
-          <a:p>
-            <a:pPr algn="ctr"/>
-          </a:p>
-        </p:txBody>
-      </p:sp>
-      <p:sp>
-        <p:nvSpPr>
-          <p:cNvPr id="47" name="TextBox 46"/>
-          <p:cNvSpPr txBox="1"/>
-          <p:nvPr/>
-        </p:nvSpPr>
-        <p:spPr>
-          <a:xfrm>
-            <a:off x="9162288" y="2304288"/>
-            <a:ext cx="2203704" cy="237744"/>
-          </a:xfrm>
-          <a:prstGeom prst="rect">
-            <a:avLst/>
-          </a:prstGeom>
-          <a:noFill/>
-        </p:spPr>
-        <p:txBody>
-          <a:bodyPr wrap="square" lIns="0" rIns="0" tIns="0" bIns="0">
-            <a:spAutoFit/>
-          </a:bodyPr>
-          <a:lstStyle/>
-          <a:p>
-            <a:pPr>
-              <a:lnSpc>
-                <a:spcPct val="108000"/>
-              </a:lnSpc>
-              <a:spcAft>
-                <a:spcPts val="700"/>
-              </a:spcAft>
-              <a:defRPr sz="1500" b="1">
-                <a:solidFill>
-                  <a:srgbClr val="FFFFFF"/>
-                </a:solidFill>
-                <a:latin typeface="Arial"/>
-              </a:defRPr>
-            </a:pPr>
-            <a:r>
-              <a:t>payments</a:t>
-            </a:r>
-          </a:p>
-        </p:txBody>
-      </p:sp>
-      <p:sp>
-        <p:nvSpPr>
-          <p:cNvPr id="48" name="TextBox 47"/>
-          <p:cNvSpPr txBox="1"/>
-          <p:nvPr/>
-        </p:nvSpPr>
-        <p:spPr>
-          <a:xfrm>
-            <a:off x="9162288" y="2907791"/>
-            <a:ext cx="2203704" cy="237744"/>
-          </a:xfrm>
-          <a:prstGeom prst="rect">
-            <a:avLst/>
-          </a:prstGeom>
-          <a:noFill/>
-        </p:spPr>
-        <p:txBody>
-          <a:bodyPr wrap="square" lIns="0" rIns="0" tIns="0" bIns="0">
-            <a:spAutoFit/>
-          </a:bodyPr>
-          <a:lstStyle/>
-          <a:p>
-            <a:pPr>
-              <a:lnSpc>
-                <a:spcPct val="108000"/>
-              </a:lnSpc>
-              <a:spcAft>
-                <a:spcPts val="700"/>
-              </a:spcAft>
-              <a:defRPr sz="1150" b="0">
-                <a:solidFill>
-                  <a:srgbClr val="63756A"/>
-                </a:solidFill>
-                <a:latin typeface="Arial"/>
-              </a:defRPr>
-            </a:pPr>
-            <a:r>
-              <a:t>payment_id · quote_id</a:t>
-            </a:r>
-          </a:p>
-        </p:txBody>
-      </p:sp>
-      <p:sp>
-        <p:nvSpPr>
-          <p:cNvPr id="49" name="Rounded Rectangle 48"/>
-          <p:cNvSpPr/>
-          <p:nvPr/>
-        </p:nvSpPr>
-        <p:spPr>
-          <a:xfrm>
-            <a:off x="658368" y="4096512"/>
-            <a:ext cx="2478024" cy="1115568"/>
-          </a:xfrm>
-          <a:prstGeom prst="roundRect">
-            <a:avLst>
-              <a:gd name="adj" fmla="val 10000"/>
-            </a:avLst>
-          </a:prstGeom>
-          <a:solidFill>
-            <a:srgbClr val="FFFFFF"/>
-          </a:solidFill>
-          <a:ln w="10160">
-            <a:solidFill>
-              <a:srgbClr val="D8E2D5"/>
-            </a:solidFill>
-          </a:ln>
-        </p:spPr>
-        <p:style>
-          <a:lnRef idx="1">
-            <a:schemeClr val="accent1"/>
-          </a:lnRef>
-          <a:fillRef idx="3">
-            <a:schemeClr val="accent1"/>
-          </a:fillRef>
-          <a:effectRef idx="2">
-            <a:schemeClr val="accent1"/>
-          </a:effectRef>
-          <a:fontRef idx="minor">
-            <a:schemeClr val="lt1"/>
-          </a:fontRef>
-        </p:style>
-        <p:txBody>
-          <a:bodyPr rtlCol="0" anchor="ctr"/>
-          <a:lstStyle/>
-          <a:p>
-            <a:pPr algn="ctr"/>
-          </a:p>
-        </p:txBody>
-      </p:sp>
-      <p:sp>
-        <p:nvSpPr>
-          <p:cNvPr id="50" name="Rounded Rectangle 49"/>
-          <p:cNvSpPr/>
-          <p:nvPr/>
-        </p:nvSpPr>
-        <p:spPr>
-          <a:xfrm>
-            <a:off x="658368" y="4096512"/>
-            <a:ext cx="2478024" cy="393192"/>
-          </a:xfrm>
-          <a:prstGeom prst="roundRect">
-            <a:avLst>
-              <a:gd name="adj" fmla="val 10000"/>
-            </a:avLst>
-          </a:prstGeom>
-          <a:solidFill>
-            <a:srgbClr val="153F32"/>
-          </a:solidFill>
-          <a:ln>
-            <a:noFill/>
-          </a:ln>
-        </p:spPr>
-        <p:style>
-          <a:lnRef idx="1">
-            <a:schemeClr val="accent1"/>
-          </a:lnRef>
-          <a:fillRef idx="3">
-            <a:schemeClr val="accent1"/>
-          </a:fillRef>
-          <a:effectRef idx="2">
-            <a:schemeClr val="accent1"/>
-          </a:effectRef>
-          <a:fontRef idx="minor">
-            <a:schemeClr val="lt1"/>
-          </a:fontRef>
-        </p:style>
-        <p:txBody>
-          <a:bodyPr rtlCol="0" anchor="ctr"/>
-          <a:lstStyle/>
-          <a:p>
-            <a:pPr algn="ctr"/>
-          </a:p>
-        </p:txBody>
-      </p:sp>
-      <p:sp>
-        <p:nvSpPr>
-          <p:cNvPr id="51" name="TextBox 50"/>
-          <p:cNvSpPr txBox="1"/>
-          <p:nvPr/>
-        </p:nvSpPr>
-        <p:spPr>
-          <a:xfrm>
-            <a:off x="795528" y="4187952"/>
-            <a:ext cx="2203704" cy="237744"/>
-          </a:xfrm>
-          <a:prstGeom prst="rect">
-            <a:avLst/>
-          </a:prstGeom>
-          <a:noFill/>
-        </p:spPr>
-        <p:txBody>
-          <a:bodyPr wrap="square" lIns="0" rIns="0" tIns="0" bIns="0">
-            <a:spAutoFit/>
-          </a:bodyPr>
-          <a:lstStyle/>
-          <a:p>
-            <a:pPr>
-              <a:lnSpc>
-                <a:spcPct val="108000"/>
-              </a:lnSpc>
-              <a:spcAft>
-                <a:spcPts val="700"/>
-              </a:spcAft>
-              <a:defRPr sz="1500" b="1">
-                <a:solidFill>
-                  <a:srgbClr val="FFFFFF"/>
-                </a:solidFill>
-                <a:latin typeface="Arial"/>
-              </a:defRPr>
-            </a:pPr>
-            <a:r>
-              <a:t>materials</a:t>
-            </a:r>
-          </a:p>
-        </p:txBody>
-      </p:sp>
-      <p:sp>
-        <p:nvSpPr>
-          <p:cNvPr id="52" name="TextBox 51"/>
-          <p:cNvSpPr txBox="1"/>
-          <p:nvPr/>
-        </p:nvSpPr>
-        <p:spPr>
-          <a:xfrm>
-            <a:off x="795528" y="4791456"/>
-            <a:ext cx="2203704" cy="237744"/>
-          </a:xfrm>
-          <a:prstGeom prst="rect">
-            <a:avLst/>
-          </a:prstGeom>
-          <a:noFill/>
-        </p:spPr>
-        <p:txBody>
-          <a:bodyPr wrap="square" lIns="0" rIns="0" tIns="0" bIns="0">
-            <a:spAutoFit/>
-          </a:bodyPr>
-          <a:lstStyle/>
-          <a:p>
-            <a:pPr>
-              <a:lnSpc>
-                <a:spcPct val="108000"/>
-              </a:lnSpc>
-              <a:spcAft>
-                <a:spcPts val="700"/>
-              </a:spcAft>
-              <a:defRPr sz="1150" b="0">
-                <a:solidFill>
-                  <a:srgbClr val="63756A"/>
-                </a:solidFill>
-                <a:latin typeface="Arial"/>
-              </a:defRPr>
-            </a:pPr>
-            <a:r>
-              <a:t>material_id · unit</a:t>
-            </a:r>
-          </a:p>
-        </p:txBody>
-      </p:sp>
-      <p:sp>
-        <p:nvSpPr>
-          <p:cNvPr id="53" name="Rounded Rectangle 52"/>
-          <p:cNvSpPr/>
-          <p:nvPr/>
-        </p:nvSpPr>
-        <p:spPr>
-          <a:xfrm>
-            <a:off x="3447288" y="4096512"/>
-            <a:ext cx="2478024" cy="1115568"/>
-          </a:xfrm>
-          <a:prstGeom prst="roundRect">
-            <a:avLst>
-              <a:gd name="adj" fmla="val 10000"/>
-            </a:avLst>
-          </a:prstGeom>
-          <a:solidFill>
-            <a:srgbClr val="FFFFFF"/>
-          </a:solidFill>
-          <a:ln w="10160">
-            <a:solidFill>
-              <a:srgbClr val="D8E2D5"/>
-            </a:solidFill>
-          </a:ln>
-        </p:spPr>
-        <p:style>
-          <a:lnRef idx="1">
-            <a:schemeClr val="accent1"/>
-          </a:lnRef>
-          <a:fillRef idx="3">
-            <a:schemeClr val="accent1"/>
-          </a:fillRef>
-          <a:effectRef idx="2">
-            <a:schemeClr val="accent1"/>
-          </a:effectRef>
-          <a:fontRef idx="minor">
-            <a:schemeClr val="lt1"/>
-          </a:fontRef>
-        </p:style>
-        <p:txBody>
-          <a:bodyPr rtlCol="0" anchor="ctr"/>
-          <a:lstStyle/>
-          <a:p>
-            <a:pPr algn="ctr"/>
-          </a:p>
-        </p:txBody>
-      </p:sp>
-      <p:sp>
-        <p:nvSpPr>
-          <p:cNvPr id="54" name="Rounded Rectangle 53"/>
-          <p:cNvSpPr/>
-          <p:nvPr/>
-        </p:nvSpPr>
-        <p:spPr>
-          <a:xfrm>
-            <a:off x="3447288" y="4096512"/>
-            <a:ext cx="2478024" cy="393192"/>
-          </a:xfrm>
-          <a:prstGeom prst="roundRect">
-            <a:avLst>
-              <a:gd name="adj" fmla="val 10000"/>
-            </a:avLst>
-          </a:prstGeom>
-          <a:solidFill>
-            <a:srgbClr val="153F32"/>
-          </a:solidFill>
-          <a:ln>
-            <a:noFill/>
-          </a:ln>
-        </p:spPr>
-        <p:style>
-          <a:lnRef idx="1">
-            <a:schemeClr val="accent1"/>
-          </a:lnRef>
-          <a:fillRef idx="3">
-            <a:schemeClr val="accent1"/>
-          </a:fillRef>
-          <a:effectRef idx="2">
-            <a:schemeClr val="accent1"/>
-          </a:effectRef>
-          <a:fontRef idx="minor">
-            <a:schemeClr val="lt1"/>
-          </a:fontRef>
-        </p:style>
-        <p:txBody>
-          <a:bodyPr rtlCol="0" anchor="ctr"/>
-          <a:lstStyle/>
-          <a:p>
-            <a:pPr algn="ctr"/>
-          </a:p>
-        </p:txBody>
-      </p:sp>
-      <p:sp>
-        <p:nvSpPr>
-          <p:cNvPr id="55" name="TextBox 54"/>
-          <p:cNvSpPr txBox="1"/>
-          <p:nvPr/>
-        </p:nvSpPr>
-        <p:spPr>
-          <a:xfrm>
-            <a:off x="3584448" y="4187952"/>
-            <a:ext cx="2203704" cy="237744"/>
-          </a:xfrm>
-          <a:prstGeom prst="rect">
-            <a:avLst/>
-          </a:prstGeom>
-          <a:noFill/>
-        </p:spPr>
-        <p:txBody>
-          <a:bodyPr wrap="square" lIns="0" rIns="0" tIns="0" bIns="0">
-            <a:spAutoFit/>
-          </a:bodyPr>
-          <a:lstStyle/>
-          <a:p>
-            <a:pPr>
-              <a:lnSpc>
-                <a:spcPct val="108000"/>
-              </a:lnSpc>
-              <a:spcAft>
-                <a:spcPts val="700"/>
-              </a:spcAft>
-              <a:defRPr sz="1500" b="1">
-                <a:solidFill>
-                  <a:srgbClr val="FFFFFF"/>
-                </a:solidFill>
-                <a:latin typeface="Arial"/>
-              </a:defRPr>
-            </a:pPr>
-            <a:r>
-              <a:t>collection_items</a:t>
-            </a:r>
-          </a:p>
-        </p:txBody>
-      </p:sp>
-      <p:sp>
-        <p:nvSpPr>
-          <p:cNvPr id="56" name="TextBox 55"/>
-          <p:cNvSpPr txBox="1"/>
-          <p:nvPr/>
-        </p:nvSpPr>
-        <p:spPr>
-          <a:xfrm>
-            <a:off x="3584448" y="4791456"/>
-            <a:ext cx="2203704" cy="237744"/>
-          </a:xfrm>
-          <a:prstGeom prst="rect">
-            <a:avLst/>
-          </a:prstGeom>
-          <a:noFill/>
-        </p:spPr>
-        <p:txBody>
-          <a:bodyPr wrap="square" lIns="0" rIns="0" tIns="0" bIns="0">
-            <a:spAutoFit/>
-          </a:bodyPr>
-          <a:lstStyle/>
-          <a:p>
-            <a:pPr>
-              <a:lnSpc>
-                <a:spcPct val="108000"/>
-              </a:lnSpc>
-              <a:spcAft>
-                <a:spcPts val="700"/>
-              </a:spcAft>
-              <a:defRPr sz="1150" b="0">
-                <a:solidFill>
-                  <a:srgbClr val="63756A"/>
-                </a:solidFill>
-                <a:latin typeface="Arial"/>
-              </a:defRPr>
-            </a:pPr>
-            <a:r>
-              <a:t>item_id · material_id</a:t>
-            </a:r>
-          </a:p>
-        </p:txBody>
-      </p:sp>
-      <p:sp>
-        <p:nvSpPr>
-          <p:cNvPr id="57" name="Rounded Rectangle 56"/>
-          <p:cNvSpPr/>
-          <p:nvPr/>
-        </p:nvSpPr>
-        <p:spPr>
-          <a:xfrm>
-            <a:off x="6236208" y="4096512"/>
-            <a:ext cx="2478024" cy="1115568"/>
-          </a:xfrm>
-          <a:prstGeom prst="roundRect">
-            <a:avLst>
-              <a:gd name="adj" fmla="val 10000"/>
-            </a:avLst>
-          </a:prstGeom>
-          <a:solidFill>
-            <a:srgbClr val="FFFFFF"/>
-          </a:solidFill>
-          <a:ln w="10160">
-            <a:solidFill>
-              <a:srgbClr val="D8E2D5"/>
-            </a:solidFill>
-          </a:ln>
-        </p:spPr>
-        <p:style>
-          <a:lnRef idx="1">
-            <a:schemeClr val="accent1"/>
-          </a:lnRef>
-          <a:fillRef idx="3">
-            <a:schemeClr val="accent1"/>
-          </a:fillRef>
-          <a:effectRef idx="2">
-            <a:schemeClr val="accent1"/>
-          </a:effectRef>
-          <a:fontRef idx="minor">
-            <a:schemeClr val="lt1"/>
-          </a:fontRef>
-        </p:style>
-        <p:txBody>
-          <a:bodyPr rtlCol="0" anchor="ctr"/>
-          <a:lstStyle/>
-          <a:p>
-            <a:pPr algn="ctr"/>
-          </a:p>
-        </p:txBody>
-      </p:sp>
-      <p:sp>
-        <p:nvSpPr>
-          <p:cNvPr id="58" name="Rounded Rectangle 57"/>
-          <p:cNvSpPr/>
-          <p:nvPr/>
-        </p:nvSpPr>
-        <p:spPr>
-          <a:xfrm>
-            <a:off x="6236208" y="4096512"/>
-            <a:ext cx="2478024" cy="393192"/>
-          </a:xfrm>
-          <a:prstGeom prst="roundRect">
-            <a:avLst>
-              <a:gd name="adj" fmla="val 10000"/>
-            </a:avLst>
-          </a:prstGeom>
-          <a:solidFill>
-            <a:srgbClr val="153F32"/>
-          </a:solidFill>
-          <a:ln>
-            <a:noFill/>
-          </a:ln>
-        </p:spPr>
-        <p:style>
-          <a:lnRef idx="1">
-            <a:schemeClr val="accent1"/>
-          </a:lnRef>
-          <a:fillRef idx="3">
-            <a:schemeClr val="accent1"/>
-          </a:fillRef>
-          <a:effectRef idx="2">
-            <a:schemeClr val="accent1"/>
-          </a:effectRef>
-          <a:fontRef idx="minor">
-            <a:schemeClr val="lt1"/>
-          </a:fontRef>
-        </p:style>
-        <p:txBody>
-          <a:bodyPr rtlCol="0" anchor="ctr"/>
-          <a:lstStyle/>
-          <a:p>
-            <a:pPr algn="ctr"/>
-          </a:p>
-        </p:txBody>
-      </p:sp>
-      <p:sp>
-        <p:nvSpPr>
-          <p:cNvPr id="59" name="TextBox 58"/>
-          <p:cNvSpPr txBox="1"/>
-          <p:nvPr/>
-        </p:nvSpPr>
-        <p:spPr>
-          <a:xfrm>
-            <a:off x="6373368" y="4187952"/>
-            <a:ext cx="2203704" cy="237744"/>
-          </a:xfrm>
-          <a:prstGeom prst="rect">
-            <a:avLst/>
-          </a:prstGeom>
-          <a:noFill/>
-        </p:spPr>
-        <p:txBody>
-          <a:bodyPr wrap="square" lIns="0" rIns="0" tIns="0" bIns="0">
-            <a:spAutoFit/>
-          </a:bodyPr>
-          <a:lstStyle/>
-          <a:p>
-            <a:pPr>
-              <a:lnSpc>
-                <a:spcPct val="108000"/>
-              </a:lnSpc>
-              <a:spcAft>
-                <a:spcPts val="700"/>
-              </a:spcAft>
-              <a:defRPr sz="1500" b="1">
-                <a:solidFill>
-                  <a:srgbClr val="FFFFFF"/>
-                </a:solidFill>
-                <a:latin typeface="Arial"/>
-              </a:defRPr>
-            </a:pPr>
-            <a:r>
-              <a:t>weighing_records</a:t>
-            </a:r>
-          </a:p>
-        </p:txBody>
-      </p:sp>
-      <p:sp>
-        <p:nvSpPr>
-          <p:cNvPr id="60" name="TextBox 59"/>
-          <p:cNvSpPr txBox="1"/>
-          <p:nvPr/>
-        </p:nvSpPr>
-        <p:spPr>
-          <a:xfrm>
-            <a:off x="6373368" y="4791456"/>
-            <a:ext cx="2203704" cy="237744"/>
-          </a:xfrm>
-          <a:prstGeom prst="rect">
-            <a:avLst/>
-          </a:prstGeom>
-          <a:noFill/>
-        </p:spPr>
-        <p:txBody>
-          <a:bodyPr wrap="square" lIns="0" rIns="0" tIns="0" bIns="0">
-            <a:spAutoFit/>
-          </a:bodyPr>
-          <a:lstStyle/>
-          <a:p>
-            <a:pPr>
-              <a:lnSpc>
-                <a:spcPct val="108000"/>
-              </a:lnSpc>
-              <a:spcAft>
-                <a:spcPts val="700"/>
-              </a:spcAft>
-              <a:defRPr sz="1150" b="0">
-                <a:solidFill>
-                  <a:srgbClr val="63756A"/>
-                </a:solidFill>
-                <a:latin typeface="Arial"/>
-              </a:defRPr>
-            </a:pPr>
-            <a:r>
-              <a:t>weighing_id · item_id</a:t>
-            </a:r>
-          </a:p>
-        </p:txBody>
-      </p:sp>
-      <p:sp>
-        <p:nvSpPr>
-          <p:cNvPr id="61" name="Rounded Rectangle 60"/>
-          <p:cNvSpPr/>
-          <p:nvPr/>
-        </p:nvSpPr>
-        <p:spPr>
-          <a:xfrm>
-            <a:off x="9025128" y="4096512"/>
-            <a:ext cx="2478024" cy="1115568"/>
-          </a:xfrm>
-          <a:prstGeom prst="roundRect">
-            <a:avLst>
-              <a:gd name="adj" fmla="val 10000"/>
-            </a:avLst>
-          </a:prstGeom>
-          <a:solidFill>
-            <a:srgbClr val="FFFFFF"/>
-          </a:solidFill>
-          <a:ln w="10160">
-            <a:solidFill>
-              <a:srgbClr val="D8E2D5"/>
-            </a:solidFill>
-          </a:ln>
-        </p:spPr>
-        <p:style>
-          <a:lnRef idx="1">
-            <a:schemeClr val="accent1"/>
-          </a:lnRef>
-          <a:fillRef idx="3">
-            <a:schemeClr val="accent1"/>
-          </a:fillRef>
-          <a:effectRef idx="2">
-            <a:schemeClr val="accent1"/>
-          </a:effectRef>
-          <a:fontRef idx="minor">
-            <a:schemeClr val="lt1"/>
-          </a:fontRef>
-        </p:style>
-        <p:txBody>
-          <a:bodyPr rtlCol="0" anchor="ctr"/>
-          <a:lstStyle/>
-          <a:p>
-            <a:pPr algn="ctr"/>
-          </a:p>
-        </p:txBody>
-      </p:sp>
-      <p:sp>
-        <p:nvSpPr>
-          <p:cNvPr id="62" name="Rounded Rectangle 61"/>
-          <p:cNvSpPr/>
-          <p:nvPr/>
-        </p:nvSpPr>
-        <p:spPr>
-          <a:xfrm>
-            <a:off x="9025128" y="4096512"/>
-            <a:ext cx="2478024" cy="393192"/>
-          </a:xfrm>
-          <a:prstGeom prst="roundRect">
-            <a:avLst>
-              <a:gd name="adj" fmla="val 10000"/>
-            </a:avLst>
-          </a:prstGeom>
-          <a:solidFill>
-            <a:srgbClr val="153F32"/>
-          </a:solidFill>
-          <a:ln>
-            <a:noFill/>
-          </a:ln>
-        </p:spPr>
-        <p:style>
-          <a:lnRef idx="1">
-            <a:schemeClr val="accent1"/>
-          </a:lnRef>
-          <a:fillRef idx="3">
-            <a:schemeClr val="accent1"/>
-          </a:fillRef>
-          <a:effectRef idx="2">
-            <a:schemeClr val="accent1"/>
-          </a:effectRef>
-          <a:fontRef idx="minor">
-            <a:schemeClr val="lt1"/>
-          </a:fontRef>
-        </p:style>
-        <p:txBody>
-          <a:bodyPr rtlCol="0" anchor="ctr"/>
-          <a:lstStyle/>
-          <a:p>
-            <a:pPr algn="ctr"/>
-          </a:p>
-        </p:txBody>
-      </p:sp>
-      <p:sp>
-        <p:nvSpPr>
-          <p:cNvPr id="63" name="TextBox 62"/>
-          <p:cNvSpPr txBox="1"/>
-          <p:nvPr/>
-        </p:nvSpPr>
-        <p:spPr>
-          <a:xfrm>
-            <a:off x="9162288" y="4187952"/>
-            <a:ext cx="2203704" cy="237744"/>
-          </a:xfrm>
-          <a:prstGeom prst="rect">
-            <a:avLst/>
-          </a:prstGeom>
-          <a:noFill/>
-        </p:spPr>
-        <p:txBody>
-          <a:bodyPr wrap="square" lIns="0" rIns="0" tIns="0" bIns="0">
-            <a:spAutoFit/>
-          </a:bodyPr>
-          <a:lstStyle/>
-          <a:p>
-            <a:pPr>
-              <a:lnSpc>
-                <a:spcPct val="108000"/>
-              </a:lnSpc>
-              <a:spcAft>
-                <a:spcPts val="700"/>
-              </a:spcAft>
-              <a:defRPr sz="1500" b="1">
-                <a:solidFill>
-                  <a:srgbClr val="FFFFFF"/>
-                </a:solidFill>
-                <a:latin typeface="Arial"/>
-              </a:defRPr>
-            </a:pPr>
-            <a:r>
-              <a:t>quote_items</a:t>
-            </a:r>
-          </a:p>
-        </p:txBody>
-      </p:sp>
-      <p:sp>
-        <p:nvSpPr>
-          <p:cNvPr id="64" name="TextBox 63"/>
-          <p:cNvSpPr txBox="1"/>
-          <p:nvPr/>
-        </p:nvSpPr>
-        <p:spPr>
-          <a:xfrm>
-            <a:off x="9162288" y="4791456"/>
-            <a:ext cx="2203704" cy="237744"/>
-          </a:xfrm>
-          <a:prstGeom prst="rect">
-            <a:avLst/>
-          </a:prstGeom>
-          <a:noFill/>
-        </p:spPr>
-        <p:txBody>
-          <a:bodyPr wrap="square" lIns="0" rIns="0" tIns="0" bIns="0">
-            <a:spAutoFit/>
-          </a:bodyPr>
-          <a:lstStyle/>
-          <a:p>
-            <a:pPr>
-              <a:lnSpc>
-                <a:spcPct val="108000"/>
-              </a:lnSpc>
-              <a:spcAft>
-                <a:spcPts val="700"/>
-              </a:spcAft>
-              <a:defRPr sz="1150" b="0">
-                <a:solidFill>
-                  <a:srgbClr val="63756A"/>
-                </a:solidFill>
-                <a:latin typeface="Arial"/>
-              </a:defRPr>
-            </a:pPr>
-            <a:r>
-              <a:t>quote_id · weighing_id</a:t>
-            </a:r>
-          </a:p>
-        </p:txBody>
-      </p:sp>
-      <p:sp>
-        <p:nvSpPr>
-          <p:cNvPr id="65" name="Rounded Rectangle 64"/>
-          <p:cNvSpPr/>
-          <p:nvPr/>
-        </p:nvSpPr>
-        <p:spPr>
-          <a:xfrm>
-            <a:off x="694944" y="5687568"/>
-            <a:ext cx="3291840" cy="329184"/>
-          </a:xfrm>
-          <a:prstGeom prst="roundRect">
-            <a:avLst>
-              <a:gd name="adj" fmla="val 10000"/>
-            </a:avLst>
-          </a:prstGeom>
-          <a:solidFill>
-            <a:srgbClr val="E8EFDF"/>
-          </a:solidFill>
-          <a:ln>
-            <a:noFill/>
-          </a:ln>
-        </p:spPr>
-        <p:style>
-          <a:lnRef idx="1">
-            <a:schemeClr val="accent1"/>
-          </a:lnRef>
-          <a:fillRef idx="3">
-            <a:schemeClr val="accent1"/>
-          </a:fillRef>
-          <a:effectRef idx="2">
-            <a:schemeClr val="accent1"/>
-          </a:effectRef>
-          <a:fontRef idx="minor">
-            <a:schemeClr val="lt1"/>
-          </a:fontRef>
-        </p:style>
-        <p:txBody>
-          <a:bodyPr rtlCol="0" anchor="ctr"/>
-          <a:lstStyle/>
-          <a:p>
-            <a:pPr algn="ctr"/>
-          </a:p>
-        </p:txBody>
-      </p:sp>
-      <p:sp>
-        <p:nvSpPr>
-          <p:cNvPr id="66" name="TextBox 65"/>
-          <p:cNvSpPr txBox="1"/>
-          <p:nvPr/>
-        </p:nvSpPr>
-        <p:spPr>
-          <a:xfrm>
-            <a:off x="804672" y="5756148"/>
-            <a:ext cx="3072384" cy="219456"/>
-          </a:xfrm>
-          <a:prstGeom prst="rect">
-            <a:avLst/>
-          </a:prstGeom>
-          <a:noFill/>
-        </p:spPr>
-        <p:txBody>
-          <a:bodyPr wrap="square" lIns="0" rIns="0" tIns="0" bIns="0">
-            <a:spAutoFit/>
-          </a:bodyPr>
-          <a:lstStyle/>
-          <a:p>
-            <a:pPr>
-              <a:lnSpc>
-                <a:spcPct val="108000"/>
-              </a:lnSpc>
-              <a:spcAft>
-                <a:spcPts val="700"/>
-              </a:spcAft>
-              <a:defRPr sz="1050" b="1">
-                <a:solidFill>
-                  <a:srgbClr val="2C6F4D"/>
-                </a:solidFill>
-                <a:latin typeface="Arial"/>
-              </a:defRPr>
-            </a:pPr>
-            <a:r>
-              <a:t>Khóa ngoại giữ quan hệ</a:t>
-            </a:r>
-          </a:p>
-        </p:txBody>
-      </p:sp>
-      <p:sp>
-        <p:nvSpPr>
-          <p:cNvPr id="67" name="Rounded Rectangle 66"/>
-          <p:cNvSpPr/>
-          <p:nvPr/>
-        </p:nvSpPr>
-        <p:spPr>
-          <a:xfrm>
-            <a:off x="4169663" y="5687568"/>
-            <a:ext cx="3291840" cy="329184"/>
-          </a:xfrm>
-          <a:prstGeom prst="roundRect">
-            <a:avLst>
-              <a:gd name="adj" fmla="val 10000"/>
-            </a:avLst>
-          </a:prstGeom>
-          <a:solidFill>
-            <a:srgbClr val="E8EFDF"/>
-          </a:solidFill>
-          <a:ln>
-            <a:noFill/>
-          </a:ln>
-        </p:spPr>
-        <p:style>
-          <a:lnRef idx="1">
-            <a:schemeClr val="accent1"/>
-          </a:lnRef>
-          <a:fillRef idx="3">
-            <a:schemeClr val="accent1"/>
-          </a:fillRef>
-          <a:effectRef idx="2">
-            <a:schemeClr val="accent1"/>
-          </a:effectRef>
-          <a:fontRef idx="minor">
-            <a:schemeClr val="lt1"/>
-          </a:fontRef>
-        </p:style>
-        <p:txBody>
-          <a:bodyPr rtlCol="0" anchor="ctr"/>
-          <a:lstStyle/>
-          <a:p>
-            <a:pPr algn="ctr"/>
-          </a:p>
-        </p:txBody>
-      </p:sp>
-      <p:sp>
-        <p:nvSpPr>
-          <p:cNvPr id="68" name="TextBox 67"/>
-          <p:cNvSpPr txBox="1"/>
-          <p:nvPr/>
-        </p:nvSpPr>
-        <p:spPr>
-          <a:xfrm>
-            <a:off x="4279392" y="5756148"/>
-            <a:ext cx="3072384" cy="219456"/>
-          </a:xfrm>
-          <a:prstGeom prst="rect">
-            <a:avLst/>
-          </a:prstGeom>
-          <a:noFill/>
-        </p:spPr>
-        <p:txBody>
-          <a:bodyPr wrap="square" lIns="0" rIns="0" tIns="0" bIns="0">
-            <a:spAutoFit/>
-          </a:bodyPr>
-          <a:lstStyle/>
-          <a:p>
-            <a:pPr>
-              <a:lnSpc>
-                <a:spcPct val="108000"/>
-              </a:lnSpc>
-              <a:spcAft>
-                <a:spcPts val="700"/>
-              </a:spcAft>
-              <a:defRPr sz="1050" b="1">
-                <a:solidFill>
-                  <a:srgbClr val="2C6F4D"/>
-                </a:solidFill>
-                <a:latin typeface="Arial"/>
-              </a:defRPr>
-            </a:pPr>
-            <a:r>
-              <a:t>Version chặn bản cũ</a:t>
-            </a:r>
-          </a:p>
-        </p:txBody>
-      </p:sp>
-      <p:sp>
-        <p:nvSpPr>
-          <p:cNvPr id="69" name="Rounded Rectangle 68"/>
-          <p:cNvSpPr/>
-          <p:nvPr/>
-        </p:nvSpPr>
-        <p:spPr>
-          <a:xfrm>
-            <a:off x="7644383" y="5687568"/>
-            <a:ext cx="3794760" cy="329184"/>
-          </a:xfrm>
-          <a:prstGeom prst="roundRect">
-            <a:avLst>
-              <a:gd name="adj" fmla="val 10000"/>
-            </a:avLst>
-          </a:prstGeom>
-          <a:solidFill>
-            <a:srgbClr val="E8EFDF"/>
-          </a:solidFill>
-          <a:ln>
-            <a:noFill/>
-          </a:ln>
-        </p:spPr>
-        <p:style>
-          <a:lnRef idx="1">
-            <a:schemeClr val="accent1"/>
-          </a:lnRef>
-          <a:fillRef idx="3">
-            <a:schemeClr val="accent1"/>
-          </a:fillRef>
-          <a:effectRef idx="2">
-            <a:schemeClr val="accent1"/>
-          </a:effectRef>
-          <a:fontRef idx="minor">
-            <a:schemeClr val="lt1"/>
-          </a:fontRef>
-        </p:style>
-        <p:txBody>
-          <a:bodyPr rtlCol="0" anchor="ctr"/>
-          <a:lstStyle/>
-          <a:p>
-            <a:pPr algn="ctr"/>
-          </a:p>
-        </p:txBody>
-      </p:sp>
-      <p:sp>
-        <p:nvSpPr>
-          <p:cNvPr id="70" name="TextBox 69"/>
-          <p:cNvSpPr txBox="1"/>
-          <p:nvPr/>
-        </p:nvSpPr>
-        <p:spPr>
-          <a:xfrm>
-            <a:off x="7754111" y="5756148"/>
-            <a:ext cx="3575304" cy="219456"/>
-          </a:xfrm>
-          <a:prstGeom prst="rect">
-            <a:avLst/>
-          </a:prstGeom>
-          <a:noFill/>
-        </p:spPr>
-        <p:txBody>
-          <a:bodyPr wrap="square" lIns="0" rIns="0" tIns="0" bIns="0">
-            <a:spAutoFit/>
-          </a:bodyPr>
-          <a:lstStyle/>
-          <a:p>
-            <a:pPr>
-              <a:lnSpc>
-                <a:spcPct val="108000"/>
-              </a:lnSpc>
-              <a:spcAft>
-                <a:spcPts val="700"/>
-              </a:spcAft>
-              <a:defRPr sz="1050" b="1">
-                <a:solidFill>
-                  <a:srgbClr val="2C6F4D"/>
-                </a:solidFill>
-                <a:latin typeface="Arial"/>
-              </a:defRPr>
-            </a:pPr>
-            <a:r>
-              <a:t>Một khoản chi hoàn tất / đơn</a:t>
+              <a:t>Đăng nhập và phân quyền theo vai trò • Thanh toán mô phỏng</a:t>
             </a:r>
           </a:p>
         </p:txBody>

</xml_diff>